<commit_message>
Add Sources IndiaClimateEnergyDashboard & StatisticsTimes
</commit_message>
<xml_diff>
--- a/task_description/Brainstorming.pptx
+++ b/task_description/Brainstorming.pptx
@@ -4,6 +4,9 @@
   <p:sldMasterIdLst>
     <p:sldMasterId id="2147483648" r:id="rId1"/>
   </p:sldMasterIdLst>
+  <p:notesMasterIdLst>
+    <p:notesMasterId r:id="rId14"/>
+  </p:notesMasterIdLst>
   <p:sldIdLst>
     <p:sldId id="263" r:id="rId2"/>
     <p:sldId id="264" r:id="rId3"/>
@@ -115,7 +118,446 @@
       </a:defRPr>
     </a:lvl9pPr>
   </p:defaultTextStyle>
+  <p:extLst>
+    <p:ext uri="{EFAFB233-063F-42B5-8137-9DF3F51BA10A}">
+      <p15:sldGuideLst xmlns:p15="http://schemas.microsoft.com/office/powerpoint/2012/main"/>
+    </p:ext>
+  </p:extLst>
 </p:presentation>
+</file>
+
+<file path=ppt/notesMasters/notesMaster1.xml><?xml version="1.0" encoding="utf-8"?>
+<p:notesMaster xmlns:a="http://schemas.openxmlformats.org/drawingml/2006/main" xmlns:r="http://schemas.openxmlformats.org/officeDocument/2006/relationships" xmlns:p="http://schemas.openxmlformats.org/presentationml/2006/main">
+  <p:cSld>
+    <p:bg>
+      <p:bgRef idx="1001">
+        <a:schemeClr val="bg1"/>
+      </p:bgRef>
+    </p:bg>
+    <p:spTree>
+      <p:nvGrpSpPr>
+        <p:cNvPr id="1" name=""/>
+        <p:cNvGrpSpPr/>
+        <p:nvPr/>
+      </p:nvGrpSpPr>
+      <p:grpSpPr>
+        <a:xfrm>
+          <a:off x="0" y="0"/>
+          <a:ext cx="0" cy="0"/>
+          <a:chOff x="0" y="0"/>
+          <a:chExt cx="0" cy="0"/>
+        </a:xfrm>
+      </p:grpSpPr>
+      <p:sp>
+        <p:nvSpPr>
+          <p:cNvPr id="2" name="Header Placeholder 1"/>
+          <p:cNvSpPr>
+            <a:spLocks noGrp="1"/>
+          </p:cNvSpPr>
+          <p:nvPr>
+            <p:ph type="hdr" sz="quarter"/>
+          </p:nvPr>
+        </p:nvSpPr>
+        <p:spPr>
+          <a:xfrm>
+            <a:off x="0" y="0"/>
+            <a:ext cx="2971800" cy="458788"/>
+          </a:xfrm>
+          <a:prstGeom prst="rect">
+            <a:avLst/>
+          </a:prstGeom>
+        </p:spPr>
+        <p:txBody>
+          <a:bodyPr vert="horz" lIns="91440" tIns="45720" rIns="91440" bIns="45720" rtlCol="0"/>
+          <a:lstStyle>
+            <a:lvl1pPr algn="l">
+              <a:defRPr sz="1200"/>
+            </a:lvl1pPr>
+          </a:lstStyle>
+          <a:p>
+            <a:endParaRPr lang="de-CH"/>
+          </a:p>
+        </p:txBody>
+      </p:sp>
+      <p:sp>
+        <p:nvSpPr>
+          <p:cNvPr id="3" name="Date Placeholder 2"/>
+          <p:cNvSpPr>
+            <a:spLocks noGrp="1"/>
+          </p:cNvSpPr>
+          <p:nvPr>
+            <p:ph type="dt" idx="1"/>
+          </p:nvPr>
+        </p:nvSpPr>
+        <p:spPr>
+          <a:xfrm>
+            <a:off x="3884613" y="0"/>
+            <a:ext cx="2971800" cy="458788"/>
+          </a:xfrm>
+          <a:prstGeom prst="rect">
+            <a:avLst/>
+          </a:prstGeom>
+        </p:spPr>
+        <p:txBody>
+          <a:bodyPr vert="horz" lIns="91440" tIns="45720" rIns="91440" bIns="45720" rtlCol="0"/>
+          <a:lstStyle>
+            <a:lvl1pPr algn="r">
+              <a:defRPr sz="1200"/>
+            </a:lvl1pPr>
+          </a:lstStyle>
+          <a:p>
+            <a:fld id="{6A49B9B3-1D81-4150-A54C-4085A238B985}" type="datetimeFigureOut">
+              <a:rPr lang="de-CH" smtClean="0"/>
+              <a:t>03.05.2025</a:t>
+            </a:fld>
+            <a:endParaRPr lang="de-CH"/>
+          </a:p>
+        </p:txBody>
+      </p:sp>
+      <p:sp>
+        <p:nvSpPr>
+          <p:cNvPr id="4" name="Slide Image Placeholder 3"/>
+          <p:cNvSpPr>
+            <a:spLocks noGrp="1" noRot="1" noChangeAspect="1"/>
+          </p:cNvSpPr>
+          <p:nvPr>
+            <p:ph type="sldImg" idx="2"/>
+          </p:nvPr>
+        </p:nvSpPr>
+        <p:spPr>
+          <a:xfrm>
+            <a:off x="685800" y="1143000"/>
+            <a:ext cx="5486400" cy="3086100"/>
+          </a:xfrm>
+          <a:prstGeom prst="rect">
+            <a:avLst/>
+          </a:prstGeom>
+          <a:noFill/>
+          <a:ln w="12700">
+            <a:solidFill>
+              <a:prstClr val="black"/>
+            </a:solidFill>
+          </a:ln>
+        </p:spPr>
+        <p:txBody>
+          <a:bodyPr vert="horz" lIns="91440" tIns="45720" rIns="91440" bIns="45720" rtlCol="0" anchor="ctr"/>
+          <a:lstStyle/>
+          <a:p>
+            <a:endParaRPr lang="de-CH"/>
+          </a:p>
+        </p:txBody>
+      </p:sp>
+      <p:sp>
+        <p:nvSpPr>
+          <p:cNvPr id="5" name="Notes Placeholder 4"/>
+          <p:cNvSpPr>
+            <a:spLocks noGrp="1"/>
+          </p:cNvSpPr>
+          <p:nvPr>
+            <p:ph type="body" sz="quarter" idx="3"/>
+          </p:nvPr>
+        </p:nvSpPr>
+        <p:spPr>
+          <a:xfrm>
+            <a:off x="685800" y="4400550"/>
+            <a:ext cx="5486400" cy="3600450"/>
+          </a:xfrm>
+          <a:prstGeom prst="rect">
+            <a:avLst/>
+          </a:prstGeom>
+        </p:spPr>
+        <p:txBody>
+          <a:bodyPr vert="horz" lIns="91440" tIns="45720" rIns="91440" bIns="45720" rtlCol="0"/>
+          <a:lstStyle/>
+          <a:p>
+            <a:pPr lvl="0"/>
+            <a:r>
+              <a:rPr lang="en-US"/>
+              <a:t>Edit Master text styles</a:t>
+            </a:r>
+          </a:p>
+          <a:p>
+            <a:pPr lvl="1"/>
+            <a:r>
+              <a:rPr lang="en-US"/>
+              <a:t>Second level</a:t>
+            </a:r>
+          </a:p>
+          <a:p>
+            <a:pPr lvl="2"/>
+            <a:r>
+              <a:rPr lang="en-US"/>
+              <a:t>Third level</a:t>
+            </a:r>
+          </a:p>
+          <a:p>
+            <a:pPr lvl="3"/>
+            <a:r>
+              <a:rPr lang="en-US"/>
+              <a:t>Fourth level</a:t>
+            </a:r>
+          </a:p>
+          <a:p>
+            <a:pPr lvl="4"/>
+            <a:r>
+              <a:rPr lang="en-US"/>
+              <a:t>Fifth level</a:t>
+            </a:r>
+            <a:endParaRPr lang="de-CH"/>
+          </a:p>
+        </p:txBody>
+      </p:sp>
+      <p:sp>
+        <p:nvSpPr>
+          <p:cNvPr id="6" name="Footer Placeholder 5"/>
+          <p:cNvSpPr>
+            <a:spLocks noGrp="1"/>
+          </p:cNvSpPr>
+          <p:nvPr>
+            <p:ph type="ftr" sz="quarter" idx="4"/>
+          </p:nvPr>
+        </p:nvSpPr>
+        <p:spPr>
+          <a:xfrm>
+            <a:off x="0" y="8685213"/>
+            <a:ext cx="2971800" cy="458787"/>
+          </a:xfrm>
+          <a:prstGeom prst="rect">
+            <a:avLst/>
+          </a:prstGeom>
+        </p:spPr>
+        <p:txBody>
+          <a:bodyPr vert="horz" lIns="91440" tIns="45720" rIns="91440" bIns="45720" rtlCol="0" anchor="b"/>
+          <a:lstStyle>
+            <a:lvl1pPr algn="l">
+              <a:defRPr sz="1200"/>
+            </a:lvl1pPr>
+          </a:lstStyle>
+          <a:p>
+            <a:endParaRPr lang="de-CH"/>
+          </a:p>
+        </p:txBody>
+      </p:sp>
+      <p:sp>
+        <p:nvSpPr>
+          <p:cNvPr id="7" name="Slide Number Placeholder 6"/>
+          <p:cNvSpPr>
+            <a:spLocks noGrp="1"/>
+          </p:cNvSpPr>
+          <p:nvPr>
+            <p:ph type="sldNum" sz="quarter" idx="5"/>
+          </p:nvPr>
+        </p:nvSpPr>
+        <p:spPr>
+          <a:xfrm>
+            <a:off x="3884613" y="8685213"/>
+            <a:ext cx="2971800" cy="458787"/>
+          </a:xfrm>
+          <a:prstGeom prst="rect">
+            <a:avLst/>
+          </a:prstGeom>
+        </p:spPr>
+        <p:txBody>
+          <a:bodyPr vert="horz" lIns="91440" tIns="45720" rIns="91440" bIns="45720" rtlCol="0" anchor="b"/>
+          <a:lstStyle>
+            <a:lvl1pPr algn="r">
+              <a:defRPr sz="1200"/>
+            </a:lvl1pPr>
+          </a:lstStyle>
+          <a:p>
+            <a:fld id="{267259FC-14D1-48B2-B0B3-4EC7838B27A7}" type="slidenum">
+              <a:rPr lang="de-CH" smtClean="0"/>
+              <a:t>‹#›</a:t>
+            </a:fld>
+            <a:endParaRPr lang="de-CH"/>
+          </a:p>
+        </p:txBody>
+      </p:sp>
+    </p:spTree>
+    <p:extLst>
+      <p:ext uri="{BB962C8B-B14F-4D97-AF65-F5344CB8AC3E}">
+        <p14:creationId xmlns:p14="http://schemas.microsoft.com/office/powerpoint/2010/main" val="507856565"/>
+      </p:ext>
+    </p:extLst>
+  </p:cSld>
+  <p:clrMap bg1="lt1" tx1="dk1" bg2="lt2" tx2="dk2" accent1="accent1" accent2="accent2" accent3="accent3" accent4="accent4" accent5="accent5" accent6="accent6" hlink="hlink" folHlink="folHlink"/>
+  <p:notesStyle>
+    <a:lvl1pPr marL="0" algn="l" defTabSz="914400" rtl="0" eaLnBrk="1" latinLnBrk="0" hangingPunct="1">
+      <a:defRPr sz="1200" kern="1200">
+        <a:solidFill>
+          <a:schemeClr val="tx1"/>
+        </a:solidFill>
+        <a:latin typeface="+mn-lt"/>
+        <a:ea typeface="+mn-ea"/>
+        <a:cs typeface="+mn-cs"/>
+      </a:defRPr>
+    </a:lvl1pPr>
+    <a:lvl2pPr marL="457200" algn="l" defTabSz="914400" rtl="0" eaLnBrk="1" latinLnBrk="0" hangingPunct="1">
+      <a:defRPr sz="1200" kern="1200">
+        <a:solidFill>
+          <a:schemeClr val="tx1"/>
+        </a:solidFill>
+        <a:latin typeface="+mn-lt"/>
+        <a:ea typeface="+mn-ea"/>
+        <a:cs typeface="+mn-cs"/>
+      </a:defRPr>
+    </a:lvl2pPr>
+    <a:lvl3pPr marL="914400" algn="l" defTabSz="914400" rtl="0" eaLnBrk="1" latinLnBrk="0" hangingPunct="1">
+      <a:defRPr sz="1200" kern="1200">
+        <a:solidFill>
+          <a:schemeClr val="tx1"/>
+        </a:solidFill>
+        <a:latin typeface="+mn-lt"/>
+        <a:ea typeface="+mn-ea"/>
+        <a:cs typeface="+mn-cs"/>
+      </a:defRPr>
+    </a:lvl3pPr>
+    <a:lvl4pPr marL="1371600" algn="l" defTabSz="914400" rtl="0" eaLnBrk="1" latinLnBrk="0" hangingPunct="1">
+      <a:defRPr sz="1200" kern="1200">
+        <a:solidFill>
+          <a:schemeClr val="tx1"/>
+        </a:solidFill>
+        <a:latin typeface="+mn-lt"/>
+        <a:ea typeface="+mn-ea"/>
+        <a:cs typeface="+mn-cs"/>
+      </a:defRPr>
+    </a:lvl4pPr>
+    <a:lvl5pPr marL="1828800" algn="l" defTabSz="914400" rtl="0" eaLnBrk="1" latinLnBrk="0" hangingPunct="1">
+      <a:defRPr sz="1200" kern="1200">
+        <a:solidFill>
+          <a:schemeClr val="tx1"/>
+        </a:solidFill>
+        <a:latin typeface="+mn-lt"/>
+        <a:ea typeface="+mn-ea"/>
+        <a:cs typeface="+mn-cs"/>
+      </a:defRPr>
+    </a:lvl5pPr>
+    <a:lvl6pPr marL="2286000" algn="l" defTabSz="914400" rtl="0" eaLnBrk="1" latinLnBrk="0" hangingPunct="1">
+      <a:defRPr sz="1200" kern="1200">
+        <a:solidFill>
+          <a:schemeClr val="tx1"/>
+        </a:solidFill>
+        <a:latin typeface="+mn-lt"/>
+        <a:ea typeface="+mn-ea"/>
+        <a:cs typeface="+mn-cs"/>
+      </a:defRPr>
+    </a:lvl6pPr>
+    <a:lvl7pPr marL="2743200" algn="l" defTabSz="914400" rtl="0" eaLnBrk="1" latinLnBrk="0" hangingPunct="1">
+      <a:defRPr sz="1200" kern="1200">
+        <a:solidFill>
+          <a:schemeClr val="tx1"/>
+        </a:solidFill>
+        <a:latin typeface="+mn-lt"/>
+        <a:ea typeface="+mn-ea"/>
+        <a:cs typeface="+mn-cs"/>
+      </a:defRPr>
+    </a:lvl7pPr>
+    <a:lvl8pPr marL="3200400" algn="l" defTabSz="914400" rtl="0" eaLnBrk="1" latinLnBrk="0" hangingPunct="1">
+      <a:defRPr sz="1200" kern="1200">
+        <a:solidFill>
+          <a:schemeClr val="tx1"/>
+        </a:solidFill>
+        <a:latin typeface="+mn-lt"/>
+        <a:ea typeface="+mn-ea"/>
+        <a:cs typeface="+mn-cs"/>
+      </a:defRPr>
+    </a:lvl8pPr>
+    <a:lvl9pPr marL="3657600" algn="l" defTabSz="914400" rtl="0" eaLnBrk="1" latinLnBrk="0" hangingPunct="1">
+      <a:defRPr sz="1200" kern="1200">
+        <a:solidFill>
+          <a:schemeClr val="tx1"/>
+        </a:solidFill>
+        <a:latin typeface="+mn-lt"/>
+        <a:ea typeface="+mn-ea"/>
+        <a:cs typeface="+mn-cs"/>
+      </a:defRPr>
+    </a:lvl9pPr>
+  </p:notesStyle>
+</p:notesMaster>
+</file>
+
+<file path=ppt/notesSlides/notesSlide1.xml><?xml version="1.0" encoding="utf-8"?>
+<p:notes xmlns:a="http://schemas.openxmlformats.org/drawingml/2006/main" xmlns:r="http://schemas.openxmlformats.org/officeDocument/2006/relationships" xmlns:p="http://schemas.openxmlformats.org/presentationml/2006/main">
+  <p:cSld>
+    <p:spTree>
+      <p:nvGrpSpPr>
+        <p:cNvPr id="1" name=""/>
+        <p:cNvGrpSpPr/>
+        <p:nvPr/>
+      </p:nvGrpSpPr>
+      <p:grpSpPr>
+        <a:xfrm>
+          <a:off x="0" y="0"/>
+          <a:ext cx="0" cy="0"/>
+          <a:chOff x="0" y="0"/>
+          <a:chExt cx="0" cy="0"/>
+        </a:xfrm>
+      </p:grpSpPr>
+      <p:sp>
+        <p:nvSpPr>
+          <p:cNvPr id="2" name="Slide Image Placeholder 1"/>
+          <p:cNvSpPr>
+            <a:spLocks noGrp="1" noRot="1" noChangeAspect="1"/>
+          </p:cNvSpPr>
+          <p:nvPr>
+            <p:ph type="sldImg"/>
+          </p:nvPr>
+        </p:nvSpPr>
+        <p:spPr/>
+      </p:sp>
+      <p:sp>
+        <p:nvSpPr>
+          <p:cNvPr id="3" name="Notes Placeholder 2"/>
+          <p:cNvSpPr>
+            <a:spLocks noGrp="1"/>
+          </p:cNvSpPr>
+          <p:nvPr>
+            <p:ph type="body" idx="1"/>
+          </p:nvPr>
+        </p:nvSpPr>
+        <p:spPr/>
+        <p:txBody>
+          <a:bodyPr/>
+          <a:lstStyle/>
+          <a:p>
+            <a:endParaRPr lang="de-CH" dirty="0"/>
+          </a:p>
+        </p:txBody>
+      </p:sp>
+      <p:sp>
+        <p:nvSpPr>
+          <p:cNvPr id="4" name="Slide Number Placeholder 3"/>
+          <p:cNvSpPr>
+            <a:spLocks noGrp="1"/>
+          </p:cNvSpPr>
+          <p:nvPr>
+            <p:ph type="sldNum" sz="quarter" idx="5"/>
+          </p:nvPr>
+        </p:nvSpPr>
+        <p:spPr/>
+        <p:txBody>
+          <a:bodyPr/>
+          <a:lstStyle/>
+          <a:p>
+            <a:fld id="{267259FC-14D1-48B2-B0B3-4EC7838B27A7}" type="slidenum">
+              <a:rPr lang="de-CH" smtClean="0"/>
+              <a:t>4</a:t>
+            </a:fld>
+            <a:endParaRPr lang="de-CH"/>
+          </a:p>
+        </p:txBody>
+      </p:sp>
+    </p:spTree>
+    <p:extLst>
+      <p:ext uri="{BB962C8B-B14F-4D97-AF65-F5344CB8AC3E}">
+        <p14:creationId xmlns:p14="http://schemas.microsoft.com/office/powerpoint/2010/main" val="915171187"/>
+      </p:ext>
+    </p:extLst>
+  </p:cSld>
+  <p:clrMapOvr>
+    <a:masterClrMapping/>
+  </p:clrMapOvr>
+</p:notes>
 </file>
 
 <file path=ppt/slideLayouts/slideLayout1.xml><?xml version="1.0" encoding="utf-8"?>
@@ -267,7 +709,7 @@
           <a:p>
             <a:fld id="{15254E24-EA96-4AD7-89AE-40EF54F67658}" type="datetimeFigureOut">
               <a:rPr lang="de-CH" smtClean="0"/>
-              <a:t>02.05.2025</a:t>
+              <a:t>03.05.2025</a:t>
             </a:fld>
             <a:endParaRPr lang="de-CH"/>
           </a:p>
@@ -467,7 +909,7 @@
           <a:p>
             <a:fld id="{15254E24-EA96-4AD7-89AE-40EF54F67658}" type="datetimeFigureOut">
               <a:rPr lang="de-CH" smtClean="0"/>
-              <a:t>02.05.2025</a:t>
+              <a:t>03.05.2025</a:t>
             </a:fld>
             <a:endParaRPr lang="de-CH"/>
           </a:p>
@@ -677,7 +1119,7 @@
           <a:p>
             <a:fld id="{15254E24-EA96-4AD7-89AE-40EF54F67658}" type="datetimeFigureOut">
               <a:rPr lang="de-CH" smtClean="0"/>
-              <a:t>02.05.2025</a:t>
+              <a:t>03.05.2025</a:t>
             </a:fld>
             <a:endParaRPr lang="de-CH"/>
           </a:p>
@@ -877,7 +1319,7 @@
           <a:p>
             <a:fld id="{15254E24-EA96-4AD7-89AE-40EF54F67658}" type="datetimeFigureOut">
               <a:rPr lang="de-CH" smtClean="0"/>
-              <a:t>02.05.2025</a:t>
+              <a:t>03.05.2025</a:t>
             </a:fld>
             <a:endParaRPr lang="de-CH"/>
           </a:p>
@@ -1153,7 +1595,7 @@
           <a:p>
             <a:fld id="{15254E24-EA96-4AD7-89AE-40EF54F67658}" type="datetimeFigureOut">
               <a:rPr lang="de-CH" smtClean="0"/>
-              <a:t>02.05.2025</a:t>
+              <a:t>03.05.2025</a:t>
             </a:fld>
             <a:endParaRPr lang="de-CH"/>
           </a:p>
@@ -1421,7 +1863,7 @@
           <a:p>
             <a:fld id="{15254E24-EA96-4AD7-89AE-40EF54F67658}" type="datetimeFigureOut">
               <a:rPr lang="de-CH" smtClean="0"/>
-              <a:t>02.05.2025</a:t>
+              <a:t>03.05.2025</a:t>
             </a:fld>
             <a:endParaRPr lang="de-CH"/>
           </a:p>
@@ -1836,7 +2278,7 @@
           <a:p>
             <a:fld id="{15254E24-EA96-4AD7-89AE-40EF54F67658}" type="datetimeFigureOut">
               <a:rPr lang="de-CH" smtClean="0"/>
-              <a:t>02.05.2025</a:t>
+              <a:t>03.05.2025</a:t>
             </a:fld>
             <a:endParaRPr lang="de-CH"/>
           </a:p>
@@ -1978,7 +2420,7 @@
           <a:p>
             <a:fld id="{15254E24-EA96-4AD7-89AE-40EF54F67658}" type="datetimeFigureOut">
               <a:rPr lang="de-CH" smtClean="0"/>
-              <a:t>02.05.2025</a:t>
+              <a:t>03.05.2025</a:t>
             </a:fld>
             <a:endParaRPr lang="de-CH"/>
           </a:p>
@@ -2091,7 +2533,7 @@
           <a:p>
             <a:fld id="{15254E24-EA96-4AD7-89AE-40EF54F67658}" type="datetimeFigureOut">
               <a:rPr lang="de-CH" smtClean="0"/>
-              <a:t>02.05.2025</a:t>
+              <a:t>03.05.2025</a:t>
             </a:fld>
             <a:endParaRPr lang="de-CH"/>
           </a:p>
@@ -2404,7 +2846,7 @@
           <a:p>
             <a:fld id="{15254E24-EA96-4AD7-89AE-40EF54F67658}" type="datetimeFigureOut">
               <a:rPr lang="de-CH" smtClean="0"/>
-              <a:t>02.05.2025</a:t>
+              <a:t>03.05.2025</a:t>
             </a:fld>
             <a:endParaRPr lang="de-CH"/>
           </a:p>
@@ -2693,7 +3135,7 @@
           <a:p>
             <a:fld id="{15254E24-EA96-4AD7-89AE-40EF54F67658}" type="datetimeFigureOut">
               <a:rPr lang="de-CH" smtClean="0"/>
-              <a:t>02.05.2025</a:t>
+              <a:t>03.05.2025</a:t>
             </a:fld>
             <a:endParaRPr lang="de-CH"/>
           </a:p>
@@ -2936,7 +3378,7 @@
           <a:p>
             <a:fld id="{15254E24-EA96-4AD7-89AE-40EF54F67658}" type="datetimeFigureOut">
               <a:rPr lang="de-CH" smtClean="0"/>
-              <a:t>02.05.2025</a:t>
+              <a:t>03.05.2025</a:t>
             </a:fld>
             <a:endParaRPr lang="de-CH"/>
           </a:p>
@@ -10533,6 +10975,161 @@
       </p:grpSpPr>
       <p:sp>
         <p:nvSpPr>
+          <p:cNvPr id="61" name="Rectangle 60">
+            <a:extLst>
+              <a:ext uri="{FF2B5EF4-FFF2-40B4-BE49-F238E27FC236}">
+                <a16:creationId xmlns:a16="http://schemas.microsoft.com/office/drawing/2014/main" id="{A249ABC2-C6AC-434C-94AA-05C184D7F5BE}"/>
+              </a:ext>
+            </a:extLst>
+          </p:cNvPr>
+          <p:cNvSpPr/>
+          <p:nvPr/>
+        </p:nvSpPr>
+        <p:spPr>
+          <a:xfrm>
+            <a:off x="3580388" y="1095374"/>
+            <a:ext cx="2339166" cy="5340565"/>
+          </a:xfrm>
+          <a:prstGeom prst="rect">
+            <a:avLst/>
+          </a:prstGeom>
+          <a:noFill/>
+          <a:ln>
+            <a:solidFill>
+              <a:schemeClr val="tx1"/>
+            </a:solidFill>
+            <a:prstDash val="dash"/>
+          </a:ln>
+        </p:spPr>
+        <p:style>
+          <a:lnRef idx="2">
+            <a:schemeClr val="accent1">
+              <a:shade val="50000"/>
+            </a:schemeClr>
+          </a:lnRef>
+          <a:fillRef idx="1">
+            <a:schemeClr val="accent1"/>
+          </a:fillRef>
+          <a:effectRef idx="0">
+            <a:schemeClr val="accent1"/>
+          </a:effectRef>
+          <a:fontRef idx="minor">
+            <a:schemeClr val="lt1"/>
+          </a:fontRef>
+        </p:style>
+        <p:txBody>
+          <a:bodyPr rtlCol="0" anchor="ctr"/>
+          <a:lstStyle/>
+          <a:p>
+            <a:pPr algn="ctr"/>
+            <a:endParaRPr lang="de-CH"/>
+          </a:p>
+        </p:txBody>
+      </p:sp>
+      <p:sp>
+        <p:nvSpPr>
+          <p:cNvPr id="43" name="Speech Bubble: Rectangle 42">
+            <a:extLst>
+              <a:ext uri="{FF2B5EF4-FFF2-40B4-BE49-F238E27FC236}">
+                <a16:creationId xmlns:a16="http://schemas.microsoft.com/office/drawing/2014/main" id="{67250CD0-22D8-4CD9-A191-6EBAD39BA314}"/>
+              </a:ext>
+            </a:extLst>
+          </p:cNvPr>
+          <p:cNvSpPr/>
+          <p:nvPr/>
+        </p:nvSpPr>
+        <p:spPr>
+          <a:xfrm>
+            <a:off x="4244277" y="0"/>
+            <a:ext cx="2181485" cy="1487567"/>
+          </a:xfrm>
+          <a:prstGeom prst="wedgeRectCallout">
+            <a:avLst>
+              <a:gd name="adj1" fmla="val -89383"/>
+              <a:gd name="adj2" fmla="val 58018"/>
+            </a:avLst>
+          </a:prstGeom>
+          <a:solidFill>
+            <a:schemeClr val="bg1"/>
+          </a:solidFill>
+          <a:ln w="38100">
+            <a:solidFill>
+              <a:schemeClr val="tx1"/>
+            </a:solidFill>
+          </a:ln>
+        </p:spPr>
+        <p:style>
+          <a:lnRef idx="2">
+            <a:schemeClr val="accent1">
+              <a:shade val="50000"/>
+            </a:schemeClr>
+          </a:lnRef>
+          <a:fillRef idx="1">
+            <a:schemeClr val="accent1"/>
+          </a:fillRef>
+          <a:effectRef idx="0">
+            <a:schemeClr val="accent1"/>
+          </a:effectRef>
+          <a:fontRef idx="minor">
+            <a:schemeClr val="lt1"/>
+          </a:fontRef>
+        </p:style>
+        <p:txBody>
+          <a:bodyPr rtlCol="0" anchor="ctr"/>
+          <a:lstStyle/>
+          <a:p>
+            <a:pPr algn="ctr"/>
+            <a:endParaRPr lang="de-CH"/>
+          </a:p>
+        </p:txBody>
+      </p:sp>
+      <p:pic>
+        <p:nvPicPr>
+          <p:cNvPr id="41" name="Picture 40">
+            <a:extLst>
+              <a:ext uri="{FF2B5EF4-FFF2-40B4-BE49-F238E27FC236}">
+                <a16:creationId xmlns:a16="http://schemas.microsoft.com/office/drawing/2014/main" id="{C27B9DB7-A172-4E5E-817C-F2ED5001DA02}"/>
+              </a:ext>
+            </a:extLst>
+          </p:cNvPr>
+          <p:cNvPicPr>
+            <a:picLocks noChangeAspect="1"/>
+          </p:cNvPicPr>
+          <p:nvPr/>
+        </p:nvPicPr>
+        <p:blipFill rotWithShape="1">
+          <a:blip r:embed="rId3">
+            <a:clrChange>
+              <a:clrFrom>
+                <a:srgbClr val="FFFFFF"/>
+              </a:clrFrom>
+              <a:clrTo>
+                <a:srgbClr val="FFFFFF">
+                  <a:alpha val="0"/>
+                </a:srgbClr>
+              </a:clrTo>
+            </a:clrChange>
+            <a:extLst>
+              <a:ext uri="{28A0092B-C50C-407E-A947-70E740481C1C}">
+                <a14:useLocalDpi xmlns:a14="http://schemas.microsoft.com/office/drawing/2010/main" val="0"/>
+              </a:ext>
+            </a:extLst>
+          </a:blip>
+          <a:srcRect l="9151" r="3944"/>
+          <a:stretch/>
+        </p:blipFill>
+        <p:spPr>
+          <a:xfrm>
+            <a:off x="4223386" y="27076"/>
+            <a:ext cx="2221230" cy="1413836"/>
+          </a:xfrm>
+          <a:prstGeom prst="rect">
+            <a:avLst/>
+          </a:prstGeom>
+        </p:spPr>
+      </p:pic>
+      <p:sp>
+        <p:nvSpPr>
           <p:cNvPr id="19" name="Rectangle 1">
             <a:extLst>
               <a:ext uri="{FF2B5EF4-FFF2-40B4-BE49-F238E27FC236}">
@@ -10639,6 +11236,2559 @@
           </a:p>
         </p:txBody>
       </p:sp>
+      <p:sp>
+        <p:nvSpPr>
+          <p:cNvPr id="2" name="Rectangle 1">
+            <a:extLst>
+              <a:ext uri="{FF2B5EF4-FFF2-40B4-BE49-F238E27FC236}">
+                <a16:creationId xmlns:a16="http://schemas.microsoft.com/office/drawing/2014/main" id="{2708C8E2-4DAE-454F-80B8-D83197D99E3A}"/>
+              </a:ext>
+            </a:extLst>
+          </p:cNvPr>
+          <p:cNvSpPr/>
+          <p:nvPr/>
+        </p:nvSpPr>
+        <p:spPr>
+          <a:xfrm>
+            <a:off x="25572" y="1409700"/>
+            <a:ext cx="2457450" cy="683657"/>
+          </a:xfrm>
+          <a:prstGeom prst="rect">
+            <a:avLst/>
+          </a:prstGeom>
+        </p:spPr>
+        <p:style>
+          <a:lnRef idx="2">
+            <a:schemeClr val="accent1">
+              <a:shade val="50000"/>
+            </a:schemeClr>
+          </a:lnRef>
+          <a:fillRef idx="1">
+            <a:schemeClr val="accent1"/>
+          </a:fillRef>
+          <a:effectRef idx="0">
+            <a:schemeClr val="accent1"/>
+          </a:effectRef>
+          <a:fontRef idx="minor">
+            <a:schemeClr val="lt1"/>
+          </a:fontRef>
+        </p:style>
+        <p:txBody>
+          <a:bodyPr rtlCol="0" anchor="ctr"/>
+          <a:lstStyle/>
+          <a:p>
+            <a:pPr algn="ctr"/>
+            <a:endParaRPr lang="de-CH"/>
+          </a:p>
+        </p:txBody>
+      </p:sp>
+      <p:sp>
+        <p:nvSpPr>
+          <p:cNvPr id="3" name="TextBox 2">
+            <a:extLst>
+              <a:ext uri="{FF2B5EF4-FFF2-40B4-BE49-F238E27FC236}">
+                <a16:creationId xmlns:a16="http://schemas.microsoft.com/office/drawing/2014/main" id="{DCC28408-A15B-43E6-A932-A0074330C588}"/>
+              </a:ext>
+            </a:extLst>
+          </p:cNvPr>
+          <p:cNvSpPr txBox="1"/>
+          <p:nvPr/>
+        </p:nvSpPr>
+        <p:spPr>
+          <a:xfrm>
+            <a:off x="-41104" y="1095375"/>
+            <a:ext cx="1367106" cy="369332"/>
+          </a:xfrm>
+          <a:prstGeom prst="rect">
+            <a:avLst/>
+          </a:prstGeom>
+          <a:noFill/>
+        </p:spPr>
+        <p:txBody>
+          <a:bodyPr wrap="none" rtlCol="0">
+            <a:spAutoFit/>
+          </a:bodyPr>
+          <a:lstStyle/>
+          <a:p>
+            <a:r>
+              <a:rPr lang="de-CH" dirty="0"/>
+              <a:t>Government</a:t>
+            </a:r>
+          </a:p>
+        </p:txBody>
+      </p:sp>
+      <p:sp>
+        <p:nvSpPr>
+          <p:cNvPr id="5" name="Rectangle 4">
+            <a:extLst>
+              <a:ext uri="{FF2B5EF4-FFF2-40B4-BE49-F238E27FC236}">
+                <a16:creationId xmlns:a16="http://schemas.microsoft.com/office/drawing/2014/main" id="{D6762932-E240-4AC4-BDC3-73E14133493C}"/>
+              </a:ext>
+            </a:extLst>
+          </p:cNvPr>
+          <p:cNvSpPr/>
+          <p:nvPr/>
+        </p:nvSpPr>
+        <p:spPr>
+          <a:xfrm>
+            <a:off x="25572" y="2428399"/>
+            <a:ext cx="2457450" cy="1362075"/>
+          </a:xfrm>
+          <a:prstGeom prst="rect">
+            <a:avLst/>
+          </a:prstGeom>
+        </p:spPr>
+        <p:style>
+          <a:lnRef idx="2">
+            <a:schemeClr val="accent1">
+              <a:shade val="50000"/>
+            </a:schemeClr>
+          </a:lnRef>
+          <a:fillRef idx="1">
+            <a:schemeClr val="accent1"/>
+          </a:fillRef>
+          <a:effectRef idx="0">
+            <a:schemeClr val="accent1"/>
+          </a:effectRef>
+          <a:fontRef idx="minor">
+            <a:schemeClr val="lt1"/>
+          </a:fontRef>
+        </p:style>
+        <p:txBody>
+          <a:bodyPr rtlCol="0" anchor="ctr"/>
+          <a:lstStyle/>
+          <a:p>
+            <a:pPr algn="ctr"/>
+            <a:endParaRPr lang="de-CH"/>
+          </a:p>
+        </p:txBody>
+      </p:sp>
+      <p:sp>
+        <p:nvSpPr>
+          <p:cNvPr id="6" name="TextBox 5">
+            <a:extLst>
+              <a:ext uri="{FF2B5EF4-FFF2-40B4-BE49-F238E27FC236}">
+                <a16:creationId xmlns:a16="http://schemas.microsoft.com/office/drawing/2014/main" id="{D4354CEB-4FDD-41E7-ABEF-8392CE912576}"/>
+              </a:ext>
+            </a:extLst>
+          </p:cNvPr>
+          <p:cNvSpPr txBox="1"/>
+          <p:nvPr/>
+        </p:nvSpPr>
+        <p:spPr>
+          <a:xfrm>
+            <a:off x="-41104" y="2114074"/>
+            <a:ext cx="1226618" cy="369332"/>
+          </a:xfrm>
+          <a:prstGeom prst="rect">
+            <a:avLst/>
+          </a:prstGeom>
+          <a:noFill/>
+        </p:spPr>
+        <p:txBody>
+          <a:bodyPr wrap="none" rtlCol="0">
+            <a:spAutoFit/>
+          </a:bodyPr>
+          <a:lstStyle/>
+          <a:p>
+            <a:r>
+              <a:rPr lang="de-CH" dirty="0"/>
+              <a:t>Companies</a:t>
+            </a:r>
+          </a:p>
+        </p:txBody>
+      </p:sp>
+      <p:sp>
+        <p:nvSpPr>
+          <p:cNvPr id="7" name="Rectangle 6">
+            <a:extLst>
+              <a:ext uri="{FF2B5EF4-FFF2-40B4-BE49-F238E27FC236}">
+                <a16:creationId xmlns:a16="http://schemas.microsoft.com/office/drawing/2014/main" id="{38C0F885-97C1-4CAF-8EE6-A3BA39EC26D5}"/>
+              </a:ext>
+            </a:extLst>
+          </p:cNvPr>
+          <p:cNvSpPr/>
+          <p:nvPr/>
+        </p:nvSpPr>
+        <p:spPr>
+          <a:xfrm>
+            <a:off x="25572" y="4191595"/>
+            <a:ext cx="2457450" cy="683657"/>
+          </a:xfrm>
+          <a:prstGeom prst="rect">
+            <a:avLst/>
+          </a:prstGeom>
+        </p:spPr>
+        <p:style>
+          <a:lnRef idx="2">
+            <a:schemeClr val="accent1">
+              <a:shade val="50000"/>
+            </a:schemeClr>
+          </a:lnRef>
+          <a:fillRef idx="1">
+            <a:schemeClr val="accent1"/>
+          </a:fillRef>
+          <a:effectRef idx="0">
+            <a:schemeClr val="accent1"/>
+          </a:effectRef>
+          <a:fontRef idx="minor">
+            <a:schemeClr val="lt1"/>
+          </a:fontRef>
+        </p:style>
+        <p:txBody>
+          <a:bodyPr rtlCol="0" anchor="ctr"/>
+          <a:lstStyle/>
+          <a:p>
+            <a:pPr algn="ctr"/>
+            <a:endParaRPr lang="de-CH"/>
+          </a:p>
+        </p:txBody>
+      </p:sp>
+      <p:sp>
+        <p:nvSpPr>
+          <p:cNvPr id="8" name="TextBox 7">
+            <a:extLst>
+              <a:ext uri="{FF2B5EF4-FFF2-40B4-BE49-F238E27FC236}">
+                <a16:creationId xmlns:a16="http://schemas.microsoft.com/office/drawing/2014/main" id="{8229A9A0-B8B9-4C0D-BC67-8DE1717D7769}"/>
+              </a:ext>
+            </a:extLst>
+          </p:cNvPr>
+          <p:cNvSpPr txBox="1"/>
+          <p:nvPr/>
+        </p:nvSpPr>
+        <p:spPr>
+          <a:xfrm>
+            <a:off x="-41104" y="3877270"/>
+            <a:ext cx="2730940" cy="369332"/>
+          </a:xfrm>
+          <a:prstGeom prst="rect">
+            <a:avLst/>
+          </a:prstGeom>
+          <a:noFill/>
+        </p:spPr>
+        <p:txBody>
+          <a:bodyPr wrap="none" rtlCol="0">
+            <a:spAutoFit/>
+          </a:bodyPr>
+          <a:lstStyle/>
+          <a:p>
+            <a:r>
+              <a:rPr lang="de-CH" dirty="0"/>
+              <a:t>International </a:t>
+            </a:r>
+            <a:r>
+              <a:rPr lang="de-CH" dirty="0" err="1"/>
+              <a:t>Organizations</a:t>
+            </a:r>
+            <a:endParaRPr lang="de-CH" dirty="0"/>
+          </a:p>
+        </p:txBody>
+      </p:sp>
+      <p:sp>
+        <p:nvSpPr>
+          <p:cNvPr id="9" name="Rectangle 8">
+            <a:extLst>
+              <a:ext uri="{FF2B5EF4-FFF2-40B4-BE49-F238E27FC236}">
+                <a16:creationId xmlns:a16="http://schemas.microsoft.com/office/drawing/2014/main" id="{CAB29B96-9CE0-4459-A983-201E4BEC1DCC}"/>
+              </a:ext>
+            </a:extLst>
+          </p:cNvPr>
+          <p:cNvSpPr/>
+          <p:nvPr/>
+        </p:nvSpPr>
+        <p:spPr>
+          <a:xfrm>
+            <a:off x="25572" y="5276373"/>
+            <a:ext cx="2457450" cy="569339"/>
+          </a:xfrm>
+          <a:prstGeom prst="rect">
+            <a:avLst/>
+          </a:prstGeom>
+        </p:spPr>
+        <p:style>
+          <a:lnRef idx="2">
+            <a:schemeClr val="accent1">
+              <a:shade val="50000"/>
+            </a:schemeClr>
+          </a:lnRef>
+          <a:fillRef idx="1">
+            <a:schemeClr val="accent1"/>
+          </a:fillRef>
+          <a:effectRef idx="0">
+            <a:schemeClr val="accent1"/>
+          </a:effectRef>
+          <a:fontRef idx="minor">
+            <a:schemeClr val="lt1"/>
+          </a:fontRef>
+        </p:style>
+        <p:txBody>
+          <a:bodyPr rtlCol="0" anchor="ctr"/>
+          <a:lstStyle/>
+          <a:p>
+            <a:pPr algn="ctr"/>
+            <a:endParaRPr lang="de-CH"/>
+          </a:p>
+        </p:txBody>
+      </p:sp>
+      <p:sp>
+        <p:nvSpPr>
+          <p:cNvPr id="10" name="TextBox 9">
+            <a:extLst>
+              <a:ext uri="{FF2B5EF4-FFF2-40B4-BE49-F238E27FC236}">
+                <a16:creationId xmlns:a16="http://schemas.microsoft.com/office/drawing/2014/main" id="{EF2CB355-4929-4839-A8C4-1AC640E3E216}"/>
+              </a:ext>
+            </a:extLst>
+          </p:cNvPr>
+          <p:cNvSpPr txBox="1"/>
+          <p:nvPr/>
+        </p:nvSpPr>
+        <p:spPr>
+          <a:xfrm>
+            <a:off x="-41104" y="4962048"/>
+            <a:ext cx="1109278" cy="369332"/>
+          </a:xfrm>
+          <a:prstGeom prst="rect">
+            <a:avLst/>
+          </a:prstGeom>
+          <a:noFill/>
+        </p:spPr>
+        <p:txBody>
+          <a:bodyPr wrap="none" rtlCol="0">
+            <a:spAutoFit/>
+          </a:bodyPr>
+          <a:lstStyle/>
+          <a:p>
+            <a:r>
+              <a:rPr lang="de-CH" dirty="0"/>
+              <a:t>Academia</a:t>
+            </a:r>
+          </a:p>
+        </p:txBody>
+      </p:sp>
+      <p:sp>
+        <p:nvSpPr>
+          <p:cNvPr id="11" name="TextBox 10">
+            <a:extLst>
+              <a:ext uri="{FF2B5EF4-FFF2-40B4-BE49-F238E27FC236}">
+                <a16:creationId xmlns:a16="http://schemas.microsoft.com/office/drawing/2014/main" id="{20562C1A-7CBF-4F4C-937F-6F6511DFEAE8}"/>
+              </a:ext>
+            </a:extLst>
+          </p:cNvPr>
+          <p:cNvSpPr txBox="1"/>
+          <p:nvPr/>
+        </p:nvSpPr>
+        <p:spPr>
+          <a:xfrm>
+            <a:off x="295271" y="5376376"/>
+            <a:ext cx="2035365" cy="369332"/>
+          </a:xfrm>
+          <a:prstGeom prst="rect">
+            <a:avLst/>
+          </a:prstGeom>
+          <a:noFill/>
+        </p:spPr>
+        <p:txBody>
+          <a:bodyPr wrap="none" rtlCol="0">
+            <a:spAutoFit/>
+          </a:bodyPr>
+          <a:lstStyle/>
+          <a:p>
+            <a:r>
+              <a:rPr lang="de-CH" dirty="0"/>
+              <a:t>Geo-Data (</a:t>
+            </a:r>
+            <a:r>
+              <a:rPr lang="de-CH" dirty="0" err="1"/>
+              <a:t>UCDavis</a:t>
+            </a:r>
+            <a:r>
+              <a:rPr lang="de-CH" dirty="0"/>
+              <a:t>)</a:t>
+            </a:r>
+          </a:p>
+        </p:txBody>
+      </p:sp>
+      <p:sp>
+        <p:nvSpPr>
+          <p:cNvPr id="12" name="TextBox 11">
+            <a:extLst>
+              <a:ext uri="{FF2B5EF4-FFF2-40B4-BE49-F238E27FC236}">
+                <a16:creationId xmlns:a16="http://schemas.microsoft.com/office/drawing/2014/main" id="{09FCFF6C-BBD6-4231-A242-33C75D4746F4}"/>
+              </a:ext>
+            </a:extLst>
+          </p:cNvPr>
+          <p:cNvSpPr txBox="1"/>
+          <p:nvPr/>
+        </p:nvSpPr>
+        <p:spPr>
+          <a:xfrm>
+            <a:off x="323662" y="2570202"/>
+            <a:ext cx="1323696" cy="369332"/>
+          </a:xfrm>
+          <a:prstGeom prst="rect">
+            <a:avLst/>
+          </a:prstGeom>
+          <a:noFill/>
+        </p:spPr>
+        <p:txBody>
+          <a:bodyPr wrap="none" rtlCol="0">
+            <a:spAutoFit/>
+          </a:bodyPr>
+          <a:lstStyle/>
+          <a:p>
+            <a:r>
+              <a:rPr lang="de-CH" dirty="0" err="1"/>
+              <a:t>Azurepower</a:t>
+            </a:r>
+            <a:endParaRPr lang="de-CH" dirty="0"/>
+          </a:p>
+        </p:txBody>
+      </p:sp>
+      <p:sp>
+        <p:nvSpPr>
+          <p:cNvPr id="13" name="TextBox 12">
+            <a:extLst>
+              <a:ext uri="{FF2B5EF4-FFF2-40B4-BE49-F238E27FC236}">
+                <a16:creationId xmlns:a16="http://schemas.microsoft.com/office/drawing/2014/main" id="{8EF28765-A19A-4836-BF9F-5F34CB255107}"/>
+              </a:ext>
+            </a:extLst>
+          </p:cNvPr>
+          <p:cNvSpPr txBox="1"/>
+          <p:nvPr/>
+        </p:nvSpPr>
+        <p:spPr>
+          <a:xfrm>
+            <a:off x="323662" y="2939534"/>
+            <a:ext cx="778418" cy="369332"/>
+          </a:xfrm>
+          <a:prstGeom prst="rect">
+            <a:avLst/>
+          </a:prstGeom>
+          <a:noFill/>
+        </p:spPr>
+        <p:txBody>
+          <a:bodyPr wrap="none" rtlCol="0">
+            <a:spAutoFit/>
+          </a:bodyPr>
+          <a:lstStyle/>
+          <a:p>
+            <a:r>
+              <a:rPr lang="de-CH" dirty="0" err="1"/>
+              <a:t>renew</a:t>
+            </a:r>
+            <a:endParaRPr lang="de-CH" dirty="0"/>
+          </a:p>
+        </p:txBody>
+      </p:sp>
+      <p:sp>
+        <p:nvSpPr>
+          <p:cNvPr id="14" name="TextBox 13">
+            <a:extLst>
+              <a:ext uri="{FF2B5EF4-FFF2-40B4-BE49-F238E27FC236}">
+                <a16:creationId xmlns:a16="http://schemas.microsoft.com/office/drawing/2014/main" id="{D1C51E68-4835-4532-8BE9-79CFEBC5CE9D}"/>
+              </a:ext>
+            </a:extLst>
+          </p:cNvPr>
+          <p:cNvSpPr txBox="1"/>
+          <p:nvPr/>
+        </p:nvSpPr>
+        <p:spPr>
+          <a:xfrm>
+            <a:off x="295271" y="3322201"/>
+            <a:ext cx="1153393" cy="369332"/>
+          </a:xfrm>
+          <a:prstGeom prst="rect">
+            <a:avLst/>
+          </a:prstGeom>
+          <a:noFill/>
+        </p:spPr>
+        <p:txBody>
+          <a:bodyPr wrap="none" rtlCol="0">
+            <a:spAutoFit/>
+          </a:bodyPr>
+          <a:lstStyle/>
+          <a:p>
+            <a:r>
+              <a:rPr lang="de-CH" dirty="0" err="1"/>
+              <a:t>tatapower</a:t>
+            </a:r>
+            <a:endParaRPr lang="de-CH" dirty="0"/>
+          </a:p>
+        </p:txBody>
+      </p:sp>
+      <p:sp>
+        <p:nvSpPr>
+          <p:cNvPr id="15" name="TextBox 14">
+            <a:extLst>
+              <a:ext uri="{FF2B5EF4-FFF2-40B4-BE49-F238E27FC236}">
+                <a16:creationId xmlns:a16="http://schemas.microsoft.com/office/drawing/2014/main" id="{63257A8A-D0CA-4225-9494-2D252021D8A6}"/>
+              </a:ext>
+            </a:extLst>
+          </p:cNvPr>
+          <p:cNvSpPr txBox="1"/>
+          <p:nvPr/>
+        </p:nvSpPr>
+        <p:spPr>
+          <a:xfrm>
+            <a:off x="187952" y="1487567"/>
+            <a:ext cx="899542" cy="369332"/>
+          </a:xfrm>
+          <a:prstGeom prst="rect">
+            <a:avLst/>
+          </a:prstGeom>
+          <a:noFill/>
+        </p:spPr>
+        <p:txBody>
+          <a:bodyPr wrap="none" rtlCol="0">
+            <a:spAutoFit/>
+          </a:bodyPr>
+          <a:lstStyle/>
+          <a:p>
+            <a:r>
+              <a:rPr lang="de-CH" dirty="0" err="1"/>
+              <a:t>tenders</a:t>
+            </a:r>
+            <a:endParaRPr lang="de-CH" dirty="0"/>
+          </a:p>
+        </p:txBody>
+      </p:sp>
+      <p:sp>
+        <p:nvSpPr>
+          <p:cNvPr id="16" name="TextBox 15">
+            <a:extLst>
+              <a:ext uri="{FF2B5EF4-FFF2-40B4-BE49-F238E27FC236}">
+                <a16:creationId xmlns:a16="http://schemas.microsoft.com/office/drawing/2014/main" id="{2D296791-4976-4472-BC08-C51847D03FC0}"/>
+              </a:ext>
+            </a:extLst>
+          </p:cNvPr>
+          <p:cNvSpPr txBox="1"/>
+          <p:nvPr/>
+        </p:nvSpPr>
+        <p:spPr>
+          <a:xfrm>
+            <a:off x="732610" y="6435940"/>
+            <a:ext cx="814647" cy="369332"/>
+          </a:xfrm>
+          <a:prstGeom prst="rect">
+            <a:avLst/>
+          </a:prstGeom>
+          <a:noFill/>
+        </p:spPr>
+        <p:txBody>
+          <a:bodyPr wrap="none" rtlCol="0">
+            <a:spAutoFit/>
+          </a:bodyPr>
+          <a:lstStyle/>
+          <a:p>
+            <a:r>
+              <a:rPr lang="de-CH" b="1" dirty="0"/>
+              <a:t>Online</a:t>
+            </a:r>
+          </a:p>
+        </p:txBody>
+      </p:sp>
+      <p:sp>
+        <p:nvSpPr>
+          <p:cNvPr id="17" name="TextBox 16">
+            <a:extLst>
+              <a:ext uri="{FF2B5EF4-FFF2-40B4-BE49-F238E27FC236}">
+                <a16:creationId xmlns:a16="http://schemas.microsoft.com/office/drawing/2014/main" id="{6EEBD66C-A299-40C5-9D0E-64158C5FBBE8}"/>
+              </a:ext>
+            </a:extLst>
+          </p:cNvPr>
+          <p:cNvSpPr txBox="1"/>
+          <p:nvPr/>
+        </p:nvSpPr>
+        <p:spPr>
+          <a:xfrm>
+            <a:off x="4244277" y="6489399"/>
+            <a:ext cx="1047338" cy="369332"/>
+          </a:xfrm>
+          <a:prstGeom prst="rect">
+            <a:avLst/>
+          </a:prstGeom>
+          <a:noFill/>
+        </p:spPr>
+        <p:txBody>
+          <a:bodyPr wrap="none" rtlCol="0">
+            <a:spAutoFit/>
+          </a:bodyPr>
+          <a:lstStyle/>
+          <a:p>
+            <a:r>
+              <a:rPr lang="de-CH" b="1" dirty="0" err="1"/>
+              <a:t>RawData</a:t>
+            </a:r>
+            <a:endParaRPr lang="de-CH" b="1" dirty="0"/>
+          </a:p>
+        </p:txBody>
+      </p:sp>
+      <p:sp>
+        <p:nvSpPr>
+          <p:cNvPr id="4" name="Oval 3">
+            <a:extLst>
+              <a:ext uri="{FF2B5EF4-FFF2-40B4-BE49-F238E27FC236}">
+                <a16:creationId xmlns:a16="http://schemas.microsoft.com/office/drawing/2014/main" id="{9924402C-FBEA-468B-B482-4914058FEF59}"/>
+              </a:ext>
+            </a:extLst>
+          </p:cNvPr>
+          <p:cNvSpPr/>
+          <p:nvPr/>
+        </p:nvSpPr>
+        <p:spPr>
+          <a:xfrm>
+            <a:off x="2947005" y="2911299"/>
+            <a:ext cx="384003" cy="382667"/>
+          </a:xfrm>
+          <a:prstGeom prst="ellipse">
+            <a:avLst/>
+          </a:prstGeom>
+          <a:solidFill>
+            <a:schemeClr val="bg1">
+              <a:lumMod val="85000"/>
+            </a:schemeClr>
+          </a:solidFill>
+          <a:ln>
+            <a:noFill/>
+          </a:ln>
+        </p:spPr>
+        <p:style>
+          <a:lnRef idx="2">
+            <a:schemeClr val="accent1">
+              <a:shade val="50000"/>
+            </a:schemeClr>
+          </a:lnRef>
+          <a:fillRef idx="1">
+            <a:schemeClr val="accent1"/>
+          </a:fillRef>
+          <a:effectRef idx="0">
+            <a:schemeClr val="accent1"/>
+          </a:effectRef>
+          <a:fontRef idx="minor">
+            <a:schemeClr val="lt1"/>
+          </a:fontRef>
+        </p:style>
+        <p:txBody>
+          <a:bodyPr rtlCol="0" anchor="ctr"/>
+          <a:lstStyle/>
+          <a:p>
+            <a:pPr algn="ctr"/>
+            <a:endParaRPr lang="de-CH"/>
+          </a:p>
+        </p:txBody>
+      </p:sp>
+      <p:sp>
+        <p:nvSpPr>
+          <p:cNvPr id="20" name="Oval 19">
+            <a:extLst>
+              <a:ext uri="{FF2B5EF4-FFF2-40B4-BE49-F238E27FC236}">
+                <a16:creationId xmlns:a16="http://schemas.microsoft.com/office/drawing/2014/main" id="{2C088CBC-55CA-4974-A85D-0051A159E844}"/>
+              </a:ext>
+            </a:extLst>
+          </p:cNvPr>
+          <p:cNvSpPr/>
+          <p:nvPr/>
+        </p:nvSpPr>
+        <p:spPr>
+          <a:xfrm>
+            <a:off x="2947007" y="1560194"/>
+            <a:ext cx="384003" cy="382667"/>
+          </a:xfrm>
+          <a:prstGeom prst="ellipse">
+            <a:avLst/>
+          </a:prstGeom>
+          <a:solidFill>
+            <a:schemeClr val="bg1">
+              <a:lumMod val="85000"/>
+            </a:schemeClr>
+          </a:solidFill>
+          <a:ln>
+            <a:noFill/>
+          </a:ln>
+        </p:spPr>
+        <p:style>
+          <a:lnRef idx="2">
+            <a:schemeClr val="accent1">
+              <a:shade val="50000"/>
+            </a:schemeClr>
+          </a:lnRef>
+          <a:fillRef idx="1">
+            <a:schemeClr val="accent1"/>
+          </a:fillRef>
+          <a:effectRef idx="0">
+            <a:schemeClr val="accent1"/>
+          </a:effectRef>
+          <a:fontRef idx="minor">
+            <a:schemeClr val="lt1"/>
+          </a:fontRef>
+        </p:style>
+        <p:txBody>
+          <a:bodyPr rtlCol="0" anchor="ctr"/>
+          <a:lstStyle/>
+          <a:p>
+            <a:pPr algn="ctr"/>
+            <a:endParaRPr lang="de-CH"/>
+          </a:p>
+        </p:txBody>
+      </p:sp>
+      <p:sp>
+        <p:nvSpPr>
+          <p:cNvPr id="21" name="Oval 20">
+            <a:extLst>
+              <a:ext uri="{FF2B5EF4-FFF2-40B4-BE49-F238E27FC236}">
+                <a16:creationId xmlns:a16="http://schemas.microsoft.com/office/drawing/2014/main" id="{7F027868-4391-4AAB-B422-09B4DAE4CDBA}"/>
+              </a:ext>
+            </a:extLst>
+          </p:cNvPr>
+          <p:cNvSpPr/>
+          <p:nvPr/>
+        </p:nvSpPr>
+        <p:spPr>
+          <a:xfrm>
+            <a:off x="2947006" y="4346853"/>
+            <a:ext cx="384003" cy="382667"/>
+          </a:xfrm>
+          <a:prstGeom prst="ellipse">
+            <a:avLst/>
+          </a:prstGeom>
+          <a:solidFill>
+            <a:schemeClr val="bg1">
+              <a:lumMod val="85000"/>
+            </a:schemeClr>
+          </a:solidFill>
+          <a:ln>
+            <a:noFill/>
+          </a:ln>
+        </p:spPr>
+        <p:style>
+          <a:lnRef idx="2">
+            <a:schemeClr val="accent1">
+              <a:shade val="50000"/>
+            </a:schemeClr>
+          </a:lnRef>
+          <a:fillRef idx="1">
+            <a:schemeClr val="accent1"/>
+          </a:fillRef>
+          <a:effectRef idx="0">
+            <a:schemeClr val="accent1"/>
+          </a:effectRef>
+          <a:fontRef idx="minor">
+            <a:schemeClr val="lt1"/>
+          </a:fontRef>
+        </p:style>
+        <p:txBody>
+          <a:bodyPr rtlCol="0" anchor="ctr"/>
+          <a:lstStyle/>
+          <a:p>
+            <a:pPr algn="ctr"/>
+            <a:endParaRPr lang="de-CH"/>
+          </a:p>
+        </p:txBody>
+      </p:sp>
+      <p:sp>
+        <p:nvSpPr>
+          <p:cNvPr id="22" name="Oval 21">
+            <a:extLst>
+              <a:ext uri="{FF2B5EF4-FFF2-40B4-BE49-F238E27FC236}">
+                <a16:creationId xmlns:a16="http://schemas.microsoft.com/office/drawing/2014/main" id="{241C9089-2F59-4E00-8FE0-A34909103EA4}"/>
+              </a:ext>
+            </a:extLst>
+          </p:cNvPr>
+          <p:cNvSpPr/>
+          <p:nvPr/>
+        </p:nvSpPr>
+        <p:spPr>
+          <a:xfrm>
+            <a:off x="2947007" y="5376376"/>
+            <a:ext cx="384003" cy="382667"/>
+          </a:xfrm>
+          <a:prstGeom prst="ellipse">
+            <a:avLst/>
+          </a:prstGeom>
+          <a:solidFill>
+            <a:schemeClr val="bg1">
+              <a:lumMod val="85000"/>
+            </a:schemeClr>
+          </a:solidFill>
+          <a:ln>
+            <a:noFill/>
+          </a:ln>
+        </p:spPr>
+        <p:style>
+          <a:lnRef idx="2">
+            <a:schemeClr val="accent1">
+              <a:shade val="50000"/>
+            </a:schemeClr>
+          </a:lnRef>
+          <a:fillRef idx="1">
+            <a:schemeClr val="accent1"/>
+          </a:fillRef>
+          <a:effectRef idx="0">
+            <a:schemeClr val="accent1"/>
+          </a:effectRef>
+          <a:fontRef idx="minor">
+            <a:schemeClr val="lt1"/>
+          </a:fontRef>
+        </p:style>
+        <p:txBody>
+          <a:bodyPr rtlCol="0" anchor="ctr"/>
+          <a:lstStyle/>
+          <a:p>
+            <a:pPr algn="ctr"/>
+            <a:endParaRPr lang="de-CH"/>
+          </a:p>
+        </p:txBody>
+      </p:sp>
+      <p:cxnSp>
+        <p:nvCxnSpPr>
+          <p:cNvPr id="23" name="Straight Arrow Connector 22">
+            <a:extLst>
+              <a:ext uri="{FF2B5EF4-FFF2-40B4-BE49-F238E27FC236}">
+                <a16:creationId xmlns:a16="http://schemas.microsoft.com/office/drawing/2014/main" id="{22965C68-418E-46F4-BBC5-57742D899805}"/>
+              </a:ext>
+            </a:extLst>
+          </p:cNvPr>
+          <p:cNvCxnSpPr>
+            <a:stCxn id="2" idx="3"/>
+            <a:endCxn id="20" idx="2"/>
+          </p:cNvCxnSpPr>
+          <p:nvPr/>
+        </p:nvCxnSpPr>
+        <p:spPr>
+          <a:xfrm flipV="1">
+            <a:off x="2483022" y="1751528"/>
+            <a:ext cx="463985" cy="1"/>
+          </a:xfrm>
+          <a:prstGeom prst="straightConnector1">
+            <a:avLst/>
+          </a:prstGeom>
+          <a:ln>
+            <a:tailEnd type="triangle"/>
+          </a:ln>
+        </p:spPr>
+        <p:style>
+          <a:lnRef idx="1">
+            <a:schemeClr val="accent1"/>
+          </a:lnRef>
+          <a:fillRef idx="0">
+            <a:schemeClr val="accent1"/>
+          </a:fillRef>
+          <a:effectRef idx="0">
+            <a:schemeClr val="accent1"/>
+          </a:effectRef>
+          <a:fontRef idx="minor">
+            <a:schemeClr val="tx1"/>
+          </a:fontRef>
+        </p:style>
+      </p:cxnSp>
+      <p:cxnSp>
+        <p:nvCxnSpPr>
+          <p:cNvPr id="24" name="Straight Arrow Connector 23">
+            <a:extLst>
+              <a:ext uri="{FF2B5EF4-FFF2-40B4-BE49-F238E27FC236}">
+                <a16:creationId xmlns:a16="http://schemas.microsoft.com/office/drawing/2014/main" id="{039B9334-341E-49C9-9D38-7C1F8A54DB0E}"/>
+              </a:ext>
+            </a:extLst>
+          </p:cNvPr>
+          <p:cNvCxnSpPr>
+            <a:cxnSpLocks/>
+            <a:stCxn id="5" idx="3"/>
+            <a:endCxn id="4" idx="2"/>
+          </p:cNvCxnSpPr>
+          <p:nvPr/>
+        </p:nvCxnSpPr>
+        <p:spPr>
+          <a:xfrm flipV="1">
+            <a:off x="2483022" y="3102633"/>
+            <a:ext cx="463983" cy="6804"/>
+          </a:xfrm>
+          <a:prstGeom prst="straightConnector1">
+            <a:avLst/>
+          </a:prstGeom>
+          <a:ln>
+            <a:tailEnd type="triangle"/>
+          </a:ln>
+        </p:spPr>
+        <p:style>
+          <a:lnRef idx="1">
+            <a:schemeClr val="accent1"/>
+          </a:lnRef>
+          <a:fillRef idx="0">
+            <a:schemeClr val="accent1"/>
+          </a:fillRef>
+          <a:effectRef idx="0">
+            <a:schemeClr val="accent1"/>
+          </a:effectRef>
+          <a:fontRef idx="minor">
+            <a:schemeClr val="tx1"/>
+          </a:fontRef>
+        </p:style>
+      </p:cxnSp>
+      <p:cxnSp>
+        <p:nvCxnSpPr>
+          <p:cNvPr id="27" name="Straight Arrow Connector 26">
+            <a:extLst>
+              <a:ext uri="{FF2B5EF4-FFF2-40B4-BE49-F238E27FC236}">
+                <a16:creationId xmlns:a16="http://schemas.microsoft.com/office/drawing/2014/main" id="{5798837A-CECB-4DA4-8600-5E2BE5EFC9BC}"/>
+              </a:ext>
+            </a:extLst>
+          </p:cNvPr>
+          <p:cNvCxnSpPr>
+            <a:cxnSpLocks/>
+            <a:stCxn id="7" idx="3"/>
+            <a:endCxn id="21" idx="2"/>
+          </p:cNvCxnSpPr>
+          <p:nvPr/>
+        </p:nvCxnSpPr>
+        <p:spPr>
+          <a:xfrm>
+            <a:off x="2483022" y="4533424"/>
+            <a:ext cx="463984" cy="4763"/>
+          </a:xfrm>
+          <a:prstGeom prst="straightConnector1">
+            <a:avLst/>
+          </a:prstGeom>
+          <a:ln>
+            <a:tailEnd type="triangle"/>
+          </a:ln>
+        </p:spPr>
+        <p:style>
+          <a:lnRef idx="1">
+            <a:schemeClr val="accent1"/>
+          </a:lnRef>
+          <a:fillRef idx="0">
+            <a:schemeClr val="accent1"/>
+          </a:fillRef>
+          <a:effectRef idx="0">
+            <a:schemeClr val="accent1"/>
+          </a:effectRef>
+          <a:fontRef idx="minor">
+            <a:schemeClr val="tx1"/>
+          </a:fontRef>
+        </p:style>
+      </p:cxnSp>
+      <p:cxnSp>
+        <p:nvCxnSpPr>
+          <p:cNvPr id="30" name="Straight Arrow Connector 29">
+            <a:extLst>
+              <a:ext uri="{FF2B5EF4-FFF2-40B4-BE49-F238E27FC236}">
+                <a16:creationId xmlns:a16="http://schemas.microsoft.com/office/drawing/2014/main" id="{8131952E-BA49-4B3B-8DA1-B73D5CEE7289}"/>
+              </a:ext>
+            </a:extLst>
+          </p:cNvPr>
+          <p:cNvCxnSpPr>
+            <a:cxnSpLocks/>
+            <a:stCxn id="9" idx="3"/>
+            <a:endCxn id="22" idx="2"/>
+          </p:cNvCxnSpPr>
+          <p:nvPr/>
+        </p:nvCxnSpPr>
+        <p:spPr>
+          <a:xfrm>
+            <a:off x="2483022" y="5561043"/>
+            <a:ext cx="463985" cy="6667"/>
+          </a:xfrm>
+          <a:prstGeom prst="straightConnector1">
+            <a:avLst/>
+          </a:prstGeom>
+          <a:ln>
+            <a:tailEnd type="triangle"/>
+          </a:ln>
+        </p:spPr>
+        <p:style>
+          <a:lnRef idx="1">
+            <a:schemeClr val="accent1"/>
+          </a:lnRef>
+          <a:fillRef idx="0">
+            <a:schemeClr val="accent1"/>
+          </a:fillRef>
+          <a:effectRef idx="0">
+            <a:schemeClr val="accent1"/>
+          </a:effectRef>
+          <a:fontRef idx="minor">
+            <a:schemeClr val="tx1"/>
+          </a:fontRef>
+        </p:style>
+      </p:cxnSp>
+      <p:sp>
+        <p:nvSpPr>
+          <p:cNvPr id="37" name="TextBox 36">
+            <a:extLst>
+              <a:ext uri="{FF2B5EF4-FFF2-40B4-BE49-F238E27FC236}">
+                <a16:creationId xmlns:a16="http://schemas.microsoft.com/office/drawing/2014/main" id="{46E8ADA9-E0BC-4881-A259-338F93FB52CA}"/>
+              </a:ext>
+            </a:extLst>
+          </p:cNvPr>
+          <p:cNvSpPr txBox="1"/>
+          <p:nvPr/>
+        </p:nvSpPr>
+        <p:spPr>
+          <a:xfrm>
+            <a:off x="7225602" y="6488668"/>
+            <a:ext cx="1592937" cy="369332"/>
+          </a:xfrm>
+          <a:prstGeom prst="rect">
+            <a:avLst/>
+          </a:prstGeom>
+          <a:noFill/>
+        </p:spPr>
+        <p:txBody>
+          <a:bodyPr wrap="none" rtlCol="0">
+            <a:spAutoFit/>
+          </a:bodyPr>
+          <a:lstStyle/>
+          <a:p>
+            <a:r>
+              <a:rPr lang="de-CH" b="1" dirty="0" err="1"/>
+              <a:t>ProcessedData</a:t>
+            </a:r>
+            <a:endParaRPr lang="de-CH" b="1" dirty="0"/>
+          </a:p>
+        </p:txBody>
+      </p:sp>
+      <p:sp>
+        <p:nvSpPr>
+          <p:cNvPr id="38" name="TextBox 37">
+            <a:extLst>
+              <a:ext uri="{FF2B5EF4-FFF2-40B4-BE49-F238E27FC236}">
+                <a16:creationId xmlns:a16="http://schemas.microsoft.com/office/drawing/2014/main" id="{B69C2C28-2EF9-42E2-AFEB-1417D7283B3C}"/>
+              </a:ext>
+            </a:extLst>
+          </p:cNvPr>
+          <p:cNvSpPr txBox="1"/>
+          <p:nvPr/>
+        </p:nvSpPr>
+        <p:spPr>
+          <a:xfrm>
+            <a:off x="10171440" y="6488668"/>
+            <a:ext cx="1077987" cy="369332"/>
+          </a:xfrm>
+          <a:prstGeom prst="rect">
+            <a:avLst/>
+          </a:prstGeom>
+          <a:noFill/>
+        </p:spPr>
+        <p:txBody>
+          <a:bodyPr wrap="none" rtlCol="0">
+            <a:spAutoFit/>
+          </a:bodyPr>
+          <a:lstStyle/>
+          <a:p>
+            <a:r>
+              <a:rPr lang="de-CH" b="1" dirty="0"/>
+              <a:t>Database</a:t>
+            </a:r>
+          </a:p>
+        </p:txBody>
+      </p:sp>
+      <p:sp>
+        <p:nvSpPr>
+          <p:cNvPr id="42" name="TextBox 41">
+            <a:extLst>
+              <a:ext uri="{FF2B5EF4-FFF2-40B4-BE49-F238E27FC236}">
+                <a16:creationId xmlns:a16="http://schemas.microsoft.com/office/drawing/2014/main" id="{C4E99775-D76D-4DFF-91B2-7B15D4AAFC37}"/>
+              </a:ext>
+            </a:extLst>
+          </p:cNvPr>
+          <p:cNvSpPr txBox="1"/>
+          <p:nvPr/>
+        </p:nvSpPr>
+        <p:spPr>
+          <a:xfrm rot="16200000">
+            <a:off x="2657619" y="6095266"/>
+            <a:ext cx="977447" cy="369332"/>
+          </a:xfrm>
+          <a:prstGeom prst="rect">
+            <a:avLst/>
+          </a:prstGeom>
+          <a:noFill/>
+        </p:spPr>
+        <p:txBody>
+          <a:bodyPr wrap="none" rtlCol="0">
+            <a:spAutoFit/>
+          </a:bodyPr>
+          <a:lstStyle/>
+          <a:p>
+            <a:r>
+              <a:rPr lang="de-CH" dirty="0" err="1"/>
+              <a:t>Scrapers</a:t>
+            </a:r>
+            <a:endParaRPr lang="de-CH" dirty="0"/>
+          </a:p>
+        </p:txBody>
+      </p:sp>
+      <p:pic>
+        <p:nvPicPr>
+          <p:cNvPr id="45" name="Picture 44">
+            <a:extLst>
+              <a:ext uri="{FF2B5EF4-FFF2-40B4-BE49-F238E27FC236}">
+                <a16:creationId xmlns:a16="http://schemas.microsoft.com/office/drawing/2014/main" id="{848B4E52-51A6-4B22-81FE-5E58D842B5E8}"/>
+              </a:ext>
+            </a:extLst>
+          </p:cNvPr>
+          <p:cNvPicPr>
+            <a:picLocks noChangeAspect="1"/>
+          </p:cNvPicPr>
+          <p:nvPr/>
+        </p:nvPicPr>
+        <p:blipFill>
+          <a:blip r:embed="rId4">
+            <a:extLst>
+              <a:ext uri="{28A0092B-C50C-407E-A947-70E740481C1C}">
+                <a14:useLocalDpi xmlns:a14="http://schemas.microsoft.com/office/drawing/2010/main" val="0"/>
+              </a:ext>
+            </a:extLst>
+          </a:blip>
+          <a:stretch>
+            <a:fillRect/>
+          </a:stretch>
+        </p:blipFill>
+        <p:spPr>
+          <a:xfrm>
+            <a:off x="10025324" y="4958852"/>
+            <a:ext cx="1356818" cy="1356818"/>
+          </a:xfrm>
+          <a:prstGeom prst="rect">
+            <a:avLst/>
+          </a:prstGeom>
+        </p:spPr>
+      </p:pic>
+      <p:pic>
+        <p:nvPicPr>
+          <p:cNvPr id="47" name="Picture 46">
+            <a:extLst>
+              <a:ext uri="{FF2B5EF4-FFF2-40B4-BE49-F238E27FC236}">
+                <a16:creationId xmlns:a16="http://schemas.microsoft.com/office/drawing/2014/main" id="{B4BEEEAC-214B-469A-AAC5-CF5BFEE44134}"/>
+              </a:ext>
+            </a:extLst>
+          </p:cNvPr>
+          <p:cNvPicPr>
+            <a:picLocks noChangeAspect="1"/>
+          </p:cNvPicPr>
+          <p:nvPr/>
+        </p:nvPicPr>
+        <p:blipFill>
+          <a:blip r:embed="rId5">
+            <a:extLst>
+              <a:ext uri="{28A0092B-C50C-407E-A947-70E740481C1C}">
+                <a14:useLocalDpi xmlns:a14="http://schemas.microsoft.com/office/drawing/2010/main" val="0"/>
+              </a:ext>
+            </a:extLst>
+          </a:blip>
+          <a:stretch>
+            <a:fillRect/>
+          </a:stretch>
+        </p:blipFill>
+        <p:spPr>
+          <a:xfrm>
+            <a:off x="10706707" y="4759879"/>
+            <a:ext cx="675435" cy="696262"/>
+          </a:xfrm>
+          <a:prstGeom prst="rect">
+            <a:avLst/>
+          </a:prstGeom>
+        </p:spPr>
+      </p:pic>
+      <p:sp>
+        <p:nvSpPr>
+          <p:cNvPr id="49" name="TextBox 48">
+            <a:extLst>
+              <a:ext uri="{FF2B5EF4-FFF2-40B4-BE49-F238E27FC236}">
+                <a16:creationId xmlns:a16="http://schemas.microsoft.com/office/drawing/2014/main" id="{BE892F8D-486E-43BE-B384-29EFCD04977F}"/>
+              </a:ext>
+            </a:extLst>
+          </p:cNvPr>
+          <p:cNvSpPr txBox="1"/>
+          <p:nvPr/>
+        </p:nvSpPr>
+        <p:spPr>
+          <a:xfrm rot="21433965">
+            <a:off x="6440748" y="72359"/>
+            <a:ext cx="1055097" cy="646331"/>
+          </a:xfrm>
+          <a:prstGeom prst="rect">
+            <a:avLst/>
+          </a:prstGeom>
+          <a:noFill/>
+        </p:spPr>
+        <p:txBody>
+          <a:bodyPr wrap="none" rtlCol="0">
+            <a:spAutoFit/>
+          </a:bodyPr>
+          <a:lstStyle/>
+          <a:p>
+            <a:r>
+              <a:rPr lang="de-CH" dirty="0" err="1"/>
+              <a:t>Selenium</a:t>
+            </a:r>
+            <a:endParaRPr lang="de-CH" dirty="0"/>
+          </a:p>
+          <a:p>
+            <a:r>
+              <a:rPr lang="de-CH" dirty="0"/>
+              <a:t>Chrome</a:t>
+            </a:r>
+          </a:p>
+        </p:txBody>
+      </p:sp>
+      <p:sp>
+        <p:nvSpPr>
+          <p:cNvPr id="50" name="TextBox 49">
+            <a:extLst>
+              <a:ext uri="{FF2B5EF4-FFF2-40B4-BE49-F238E27FC236}">
+                <a16:creationId xmlns:a16="http://schemas.microsoft.com/office/drawing/2014/main" id="{F926D579-B1C0-474F-9915-63E1F400AD9E}"/>
+              </a:ext>
+            </a:extLst>
+          </p:cNvPr>
+          <p:cNvSpPr txBox="1"/>
+          <p:nvPr/>
+        </p:nvSpPr>
+        <p:spPr>
+          <a:xfrm rot="21433965">
+            <a:off x="10613388" y="4245678"/>
+            <a:ext cx="1245277" cy="369332"/>
+          </a:xfrm>
+          <a:prstGeom prst="rect">
+            <a:avLst/>
+          </a:prstGeom>
+          <a:noFill/>
+        </p:spPr>
+        <p:txBody>
+          <a:bodyPr wrap="none" rtlCol="0">
+            <a:spAutoFit/>
+          </a:bodyPr>
+          <a:lstStyle/>
+          <a:p>
+            <a:r>
+              <a:rPr lang="de-CH" dirty="0"/>
+              <a:t>PostgreSQL</a:t>
+            </a:r>
+          </a:p>
+        </p:txBody>
+      </p:sp>
+      <p:sp>
+        <p:nvSpPr>
+          <p:cNvPr id="51" name="Oval 50">
+            <a:extLst>
+              <a:ext uri="{FF2B5EF4-FFF2-40B4-BE49-F238E27FC236}">
+                <a16:creationId xmlns:a16="http://schemas.microsoft.com/office/drawing/2014/main" id="{8BE02B61-55DC-4BCD-93B0-863B97B85231}"/>
+              </a:ext>
+            </a:extLst>
+          </p:cNvPr>
+          <p:cNvSpPr/>
+          <p:nvPr/>
+        </p:nvSpPr>
+        <p:spPr>
+          <a:xfrm>
+            <a:off x="9177338" y="5445927"/>
+            <a:ext cx="384003" cy="382667"/>
+          </a:xfrm>
+          <a:prstGeom prst="ellipse">
+            <a:avLst/>
+          </a:prstGeom>
+          <a:solidFill>
+            <a:schemeClr val="bg1">
+              <a:lumMod val="85000"/>
+            </a:schemeClr>
+          </a:solidFill>
+          <a:ln>
+            <a:noFill/>
+          </a:ln>
+        </p:spPr>
+        <p:style>
+          <a:lnRef idx="2">
+            <a:schemeClr val="accent1">
+              <a:shade val="50000"/>
+            </a:schemeClr>
+          </a:lnRef>
+          <a:fillRef idx="1">
+            <a:schemeClr val="accent1"/>
+          </a:fillRef>
+          <a:effectRef idx="0">
+            <a:schemeClr val="accent1"/>
+          </a:effectRef>
+          <a:fontRef idx="minor">
+            <a:schemeClr val="lt1"/>
+          </a:fontRef>
+        </p:style>
+        <p:txBody>
+          <a:bodyPr rtlCol="0" anchor="ctr"/>
+          <a:lstStyle/>
+          <a:p>
+            <a:pPr algn="ctr"/>
+            <a:endParaRPr lang="de-CH"/>
+          </a:p>
+        </p:txBody>
+      </p:sp>
+      <p:cxnSp>
+        <p:nvCxnSpPr>
+          <p:cNvPr id="52" name="Straight Arrow Connector 51">
+            <a:extLst>
+              <a:ext uri="{FF2B5EF4-FFF2-40B4-BE49-F238E27FC236}">
+                <a16:creationId xmlns:a16="http://schemas.microsoft.com/office/drawing/2014/main" id="{2774C2E0-9528-420B-98C5-7E418B0CC5CB}"/>
+              </a:ext>
+            </a:extLst>
+          </p:cNvPr>
+          <p:cNvCxnSpPr>
+            <a:cxnSpLocks/>
+            <a:stCxn id="51" idx="6"/>
+            <a:endCxn id="45" idx="1"/>
+          </p:cNvCxnSpPr>
+          <p:nvPr/>
+        </p:nvCxnSpPr>
+        <p:spPr>
+          <a:xfrm>
+            <a:off x="9561341" y="5637261"/>
+            <a:ext cx="463983" cy="0"/>
+          </a:xfrm>
+          <a:prstGeom prst="straightConnector1">
+            <a:avLst/>
+          </a:prstGeom>
+          <a:ln>
+            <a:tailEnd type="triangle"/>
+          </a:ln>
+        </p:spPr>
+        <p:style>
+          <a:lnRef idx="1">
+            <a:schemeClr val="accent1"/>
+          </a:lnRef>
+          <a:fillRef idx="0">
+            <a:schemeClr val="accent1"/>
+          </a:fillRef>
+          <a:effectRef idx="0">
+            <a:schemeClr val="accent1"/>
+          </a:effectRef>
+          <a:fontRef idx="minor">
+            <a:schemeClr val="tx1"/>
+          </a:fontRef>
+        </p:style>
+      </p:cxnSp>
+      <p:sp>
+        <p:nvSpPr>
+          <p:cNvPr id="56" name="Oval 55">
+            <a:extLst>
+              <a:ext uri="{FF2B5EF4-FFF2-40B4-BE49-F238E27FC236}">
+                <a16:creationId xmlns:a16="http://schemas.microsoft.com/office/drawing/2014/main" id="{3BEB1B66-9005-4AA2-BC7D-3481CA7007AF}"/>
+              </a:ext>
+            </a:extLst>
+          </p:cNvPr>
+          <p:cNvSpPr/>
+          <p:nvPr/>
+        </p:nvSpPr>
+        <p:spPr>
+          <a:xfrm>
+            <a:off x="6183640" y="2741533"/>
+            <a:ext cx="384003" cy="382667"/>
+          </a:xfrm>
+          <a:prstGeom prst="ellipse">
+            <a:avLst/>
+          </a:prstGeom>
+          <a:solidFill>
+            <a:schemeClr val="bg1">
+              <a:lumMod val="85000"/>
+            </a:schemeClr>
+          </a:solidFill>
+          <a:ln>
+            <a:noFill/>
+          </a:ln>
+        </p:spPr>
+        <p:style>
+          <a:lnRef idx="2">
+            <a:schemeClr val="accent1">
+              <a:shade val="50000"/>
+            </a:schemeClr>
+          </a:lnRef>
+          <a:fillRef idx="1">
+            <a:schemeClr val="accent1"/>
+          </a:fillRef>
+          <a:effectRef idx="0">
+            <a:schemeClr val="accent1"/>
+          </a:effectRef>
+          <a:fontRef idx="minor">
+            <a:schemeClr val="lt1"/>
+          </a:fontRef>
+        </p:style>
+        <p:txBody>
+          <a:bodyPr rtlCol="0" anchor="ctr"/>
+          <a:lstStyle/>
+          <a:p>
+            <a:pPr algn="ctr"/>
+            <a:endParaRPr lang="de-CH"/>
+          </a:p>
+        </p:txBody>
+      </p:sp>
+      <p:sp>
+        <p:nvSpPr>
+          <p:cNvPr id="59" name="TextBox 58">
+            <a:extLst>
+              <a:ext uri="{FF2B5EF4-FFF2-40B4-BE49-F238E27FC236}">
+                <a16:creationId xmlns:a16="http://schemas.microsoft.com/office/drawing/2014/main" id="{FC82F039-66CB-4E29-8752-F6B1A7A72E95}"/>
+              </a:ext>
+            </a:extLst>
+          </p:cNvPr>
+          <p:cNvSpPr txBox="1"/>
+          <p:nvPr/>
+        </p:nvSpPr>
+        <p:spPr>
+          <a:xfrm rot="21433965">
+            <a:off x="7202592" y="747116"/>
+            <a:ext cx="852413" cy="369332"/>
+          </a:xfrm>
+          <a:prstGeom prst="rect">
+            <a:avLst/>
+          </a:prstGeom>
+          <a:noFill/>
+        </p:spPr>
+        <p:txBody>
+          <a:bodyPr wrap="none" rtlCol="0">
+            <a:spAutoFit/>
+          </a:bodyPr>
+          <a:lstStyle/>
+          <a:p>
+            <a:r>
+              <a:rPr lang="de-CH" dirty="0"/>
+              <a:t>Python</a:t>
+            </a:r>
+          </a:p>
+        </p:txBody>
+      </p:sp>
+      <p:sp>
+        <p:nvSpPr>
+          <p:cNvPr id="60" name="Rectangle 59">
+            <a:extLst>
+              <a:ext uri="{FF2B5EF4-FFF2-40B4-BE49-F238E27FC236}">
+                <a16:creationId xmlns:a16="http://schemas.microsoft.com/office/drawing/2014/main" id="{2DFEB928-3216-4169-86EA-00275512AB74}"/>
+              </a:ext>
+            </a:extLst>
+          </p:cNvPr>
+          <p:cNvSpPr/>
+          <p:nvPr/>
+        </p:nvSpPr>
+        <p:spPr>
+          <a:xfrm>
+            <a:off x="-47625" y="1095375"/>
+            <a:ext cx="2753245" cy="5340565"/>
+          </a:xfrm>
+          <a:prstGeom prst="rect">
+            <a:avLst/>
+          </a:prstGeom>
+          <a:noFill/>
+          <a:ln>
+            <a:solidFill>
+              <a:schemeClr val="tx1"/>
+            </a:solidFill>
+            <a:prstDash val="dash"/>
+          </a:ln>
+        </p:spPr>
+        <p:style>
+          <a:lnRef idx="2">
+            <a:schemeClr val="accent1">
+              <a:shade val="50000"/>
+            </a:schemeClr>
+          </a:lnRef>
+          <a:fillRef idx="1">
+            <a:schemeClr val="accent1"/>
+          </a:fillRef>
+          <a:effectRef idx="0">
+            <a:schemeClr val="accent1"/>
+          </a:effectRef>
+          <a:fontRef idx="minor">
+            <a:schemeClr val="lt1"/>
+          </a:fontRef>
+        </p:style>
+        <p:txBody>
+          <a:bodyPr rtlCol="0" anchor="ctr"/>
+          <a:lstStyle/>
+          <a:p>
+            <a:pPr algn="ctr"/>
+            <a:endParaRPr lang="de-CH"/>
+          </a:p>
+        </p:txBody>
+      </p:sp>
+      <p:sp>
+        <p:nvSpPr>
+          <p:cNvPr id="62" name="Oval 61">
+            <a:extLst>
+              <a:ext uri="{FF2B5EF4-FFF2-40B4-BE49-F238E27FC236}">
+                <a16:creationId xmlns:a16="http://schemas.microsoft.com/office/drawing/2014/main" id="{68BBDCDB-DFC0-4899-8B7B-96986B61FDBD}"/>
+              </a:ext>
+            </a:extLst>
+          </p:cNvPr>
+          <p:cNvSpPr/>
+          <p:nvPr/>
+        </p:nvSpPr>
+        <p:spPr>
+          <a:xfrm>
+            <a:off x="6188619" y="4262188"/>
+            <a:ext cx="384003" cy="382667"/>
+          </a:xfrm>
+          <a:prstGeom prst="ellipse">
+            <a:avLst/>
+          </a:prstGeom>
+          <a:solidFill>
+            <a:schemeClr val="bg1">
+              <a:lumMod val="85000"/>
+            </a:schemeClr>
+          </a:solidFill>
+          <a:ln>
+            <a:noFill/>
+          </a:ln>
+        </p:spPr>
+        <p:style>
+          <a:lnRef idx="2">
+            <a:schemeClr val="accent1">
+              <a:shade val="50000"/>
+            </a:schemeClr>
+          </a:lnRef>
+          <a:fillRef idx="1">
+            <a:schemeClr val="accent1"/>
+          </a:fillRef>
+          <a:effectRef idx="0">
+            <a:schemeClr val="accent1"/>
+          </a:effectRef>
+          <a:fontRef idx="minor">
+            <a:schemeClr val="lt1"/>
+          </a:fontRef>
+        </p:style>
+        <p:txBody>
+          <a:bodyPr rtlCol="0" anchor="ctr"/>
+          <a:lstStyle/>
+          <a:p>
+            <a:pPr algn="ctr"/>
+            <a:endParaRPr lang="de-CH"/>
+          </a:p>
+        </p:txBody>
+      </p:sp>
+      <p:sp>
+        <p:nvSpPr>
+          <p:cNvPr id="63" name="Rectangle 62">
+            <a:extLst>
+              <a:ext uri="{FF2B5EF4-FFF2-40B4-BE49-F238E27FC236}">
+                <a16:creationId xmlns:a16="http://schemas.microsoft.com/office/drawing/2014/main" id="{40D08E03-8FA9-4FCE-BEA3-DABC4A6EDDC4}"/>
+              </a:ext>
+            </a:extLst>
+          </p:cNvPr>
+          <p:cNvSpPr/>
+          <p:nvPr/>
+        </p:nvSpPr>
+        <p:spPr>
+          <a:xfrm>
+            <a:off x="6687360" y="1120190"/>
+            <a:ext cx="2339166" cy="5340565"/>
+          </a:xfrm>
+          <a:prstGeom prst="rect">
+            <a:avLst/>
+          </a:prstGeom>
+          <a:noFill/>
+          <a:ln>
+            <a:solidFill>
+              <a:schemeClr val="tx1"/>
+            </a:solidFill>
+            <a:prstDash val="dash"/>
+          </a:ln>
+        </p:spPr>
+        <p:style>
+          <a:lnRef idx="2">
+            <a:schemeClr val="accent1">
+              <a:shade val="50000"/>
+            </a:schemeClr>
+          </a:lnRef>
+          <a:fillRef idx="1">
+            <a:schemeClr val="accent1"/>
+          </a:fillRef>
+          <a:effectRef idx="0">
+            <a:schemeClr val="accent1"/>
+          </a:effectRef>
+          <a:fontRef idx="minor">
+            <a:schemeClr val="lt1"/>
+          </a:fontRef>
+        </p:style>
+        <p:txBody>
+          <a:bodyPr rtlCol="0" anchor="ctr"/>
+          <a:lstStyle/>
+          <a:p>
+            <a:pPr algn="ctr"/>
+            <a:endParaRPr lang="de-CH"/>
+          </a:p>
+        </p:txBody>
+      </p:sp>
+      <p:pic>
+        <p:nvPicPr>
+          <p:cNvPr id="58" name="Picture 57">
+            <a:extLst>
+              <a:ext uri="{FF2B5EF4-FFF2-40B4-BE49-F238E27FC236}">
+                <a16:creationId xmlns:a16="http://schemas.microsoft.com/office/drawing/2014/main" id="{D4416D2C-2FEA-4538-B24D-27DACA5FF8BC}"/>
+              </a:ext>
+            </a:extLst>
+          </p:cNvPr>
+          <p:cNvPicPr>
+            <a:picLocks noChangeAspect="1"/>
+          </p:cNvPicPr>
+          <p:nvPr/>
+        </p:nvPicPr>
+        <p:blipFill>
+          <a:blip r:embed="rId6">
+            <a:extLst>
+              <a:ext uri="{28A0092B-C50C-407E-A947-70E740481C1C}">
+                <a14:useLocalDpi xmlns:a14="http://schemas.microsoft.com/office/drawing/2010/main" val="0"/>
+              </a:ext>
+            </a:extLst>
+          </a:blip>
+          <a:stretch>
+            <a:fillRect/>
+          </a:stretch>
+        </p:blipFill>
+        <p:spPr>
+          <a:xfrm>
+            <a:off x="6546301" y="747244"/>
+            <a:ext cx="696262" cy="696262"/>
+          </a:xfrm>
+          <a:prstGeom prst="rect">
+            <a:avLst/>
+          </a:prstGeom>
+        </p:spPr>
+      </p:pic>
+      <p:sp>
+        <p:nvSpPr>
+          <p:cNvPr id="64" name="Oval 63">
+            <a:extLst>
+              <a:ext uri="{FF2B5EF4-FFF2-40B4-BE49-F238E27FC236}">
+                <a16:creationId xmlns:a16="http://schemas.microsoft.com/office/drawing/2014/main" id="{D499E57A-C6A7-48D2-A9D1-737E0F17D428}"/>
+              </a:ext>
+            </a:extLst>
+          </p:cNvPr>
+          <p:cNvSpPr/>
+          <p:nvPr/>
+        </p:nvSpPr>
+        <p:spPr>
+          <a:xfrm>
+            <a:off x="9141264" y="2697570"/>
+            <a:ext cx="384003" cy="382667"/>
+          </a:xfrm>
+          <a:prstGeom prst="ellipse">
+            <a:avLst/>
+          </a:prstGeom>
+          <a:solidFill>
+            <a:schemeClr val="bg1">
+              <a:lumMod val="85000"/>
+            </a:schemeClr>
+          </a:solidFill>
+          <a:ln>
+            <a:noFill/>
+          </a:ln>
+        </p:spPr>
+        <p:style>
+          <a:lnRef idx="2">
+            <a:schemeClr val="accent1">
+              <a:shade val="50000"/>
+            </a:schemeClr>
+          </a:lnRef>
+          <a:fillRef idx="1">
+            <a:schemeClr val="accent1"/>
+          </a:fillRef>
+          <a:effectRef idx="0">
+            <a:schemeClr val="accent1"/>
+          </a:effectRef>
+          <a:fontRef idx="minor">
+            <a:schemeClr val="lt1"/>
+          </a:fontRef>
+        </p:style>
+        <p:txBody>
+          <a:bodyPr rtlCol="0" anchor="ctr"/>
+          <a:lstStyle/>
+          <a:p>
+            <a:pPr algn="ctr"/>
+            <a:endParaRPr lang="de-CH"/>
+          </a:p>
+        </p:txBody>
+      </p:sp>
+      <p:sp>
+        <p:nvSpPr>
+          <p:cNvPr id="65" name="Oval 64">
+            <a:extLst>
+              <a:ext uri="{FF2B5EF4-FFF2-40B4-BE49-F238E27FC236}">
+                <a16:creationId xmlns:a16="http://schemas.microsoft.com/office/drawing/2014/main" id="{357F8866-E84E-4701-9272-CAA7ED7C6E1A}"/>
+              </a:ext>
+            </a:extLst>
+          </p:cNvPr>
+          <p:cNvSpPr/>
+          <p:nvPr/>
+        </p:nvSpPr>
+        <p:spPr>
+          <a:xfrm>
+            <a:off x="10413196" y="3322201"/>
+            <a:ext cx="384003" cy="382667"/>
+          </a:xfrm>
+          <a:prstGeom prst="ellipse">
+            <a:avLst/>
+          </a:prstGeom>
+          <a:solidFill>
+            <a:schemeClr val="bg1">
+              <a:lumMod val="85000"/>
+            </a:schemeClr>
+          </a:solidFill>
+          <a:ln>
+            <a:noFill/>
+          </a:ln>
+        </p:spPr>
+        <p:style>
+          <a:lnRef idx="2">
+            <a:schemeClr val="accent1">
+              <a:shade val="50000"/>
+            </a:schemeClr>
+          </a:lnRef>
+          <a:fillRef idx="1">
+            <a:schemeClr val="accent1"/>
+          </a:fillRef>
+          <a:effectRef idx="0">
+            <a:schemeClr val="accent1"/>
+          </a:effectRef>
+          <a:fontRef idx="minor">
+            <a:schemeClr val="lt1"/>
+          </a:fontRef>
+        </p:style>
+        <p:txBody>
+          <a:bodyPr rtlCol="0" anchor="ctr"/>
+          <a:lstStyle/>
+          <a:p>
+            <a:pPr algn="ctr"/>
+            <a:endParaRPr lang="de-CH"/>
+          </a:p>
+        </p:txBody>
+      </p:sp>
+      <p:cxnSp>
+        <p:nvCxnSpPr>
+          <p:cNvPr id="66" name="Straight Arrow Connector 65">
+            <a:extLst>
+              <a:ext uri="{FF2B5EF4-FFF2-40B4-BE49-F238E27FC236}">
+                <a16:creationId xmlns:a16="http://schemas.microsoft.com/office/drawing/2014/main" id="{78752445-C6FC-4C2D-823E-EC0B12137B64}"/>
+              </a:ext>
+            </a:extLst>
+          </p:cNvPr>
+          <p:cNvCxnSpPr>
+            <a:cxnSpLocks/>
+            <a:stCxn id="50" idx="1"/>
+            <a:endCxn id="65" idx="4"/>
+          </p:cNvCxnSpPr>
+          <p:nvPr/>
+        </p:nvCxnSpPr>
+        <p:spPr>
+          <a:xfrm flipH="1" flipV="1">
+            <a:off x="10605198" y="3704868"/>
+            <a:ext cx="8916" cy="755536"/>
+          </a:xfrm>
+          <a:prstGeom prst="straightConnector1">
+            <a:avLst/>
+          </a:prstGeom>
+          <a:ln>
+            <a:tailEnd type="triangle"/>
+          </a:ln>
+        </p:spPr>
+        <p:style>
+          <a:lnRef idx="1">
+            <a:schemeClr val="accent1"/>
+          </a:lnRef>
+          <a:fillRef idx="0">
+            <a:schemeClr val="accent1"/>
+          </a:fillRef>
+          <a:effectRef idx="0">
+            <a:schemeClr val="accent1"/>
+          </a:effectRef>
+          <a:fontRef idx="minor">
+            <a:schemeClr val="tx1"/>
+          </a:fontRef>
+        </p:style>
+      </p:cxnSp>
+      <p:cxnSp>
+        <p:nvCxnSpPr>
+          <p:cNvPr id="69" name="Straight Arrow Connector 68">
+            <a:extLst>
+              <a:ext uri="{FF2B5EF4-FFF2-40B4-BE49-F238E27FC236}">
+                <a16:creationId xmlns:a16="http://schemas.microsoft.com/office/drawing/2014/main" id="{6F28C591-752B-43F6-918A-5823E724C71A}"/>
+              </a:ext>
+            </a:extLst>
+          </p:cNvPr>
+          <p:cNvCxnSpPr>
+            <a:cxnSpLocks/>
+            <a:stCxn id="64" idx="6"/>
+          </p:cNvCxnSpPr>
+          <p:nvPr/>
+        </p:nvCxnSpPr>
+        <p:spPr>
+          <a:xfrm flipV="1">
+            <a:off x="9525267" y="2463935"/>
+            <a:ext cx="500057" cy="424969"/>
+          </a:xfrm>
+          <a:prstGeom prst="straightConnector1">
+            <a:avLst/>
+          </a:prstGeom>
+          <a:ln>
+            <a:tailEnd type="triangle"/>
+          </a:ln>
+        </p:spPr>
+        <p:style>
+          <a:lnRef idx="1">
+            <a:schemeClr val="accent1"/>
+          </a:lnRef>
+          <a:fillRef idx="0">
+            <a:schemeClr val="accent1"/>
+          </a:fillRef>
+          <a:effectRef idx="0">
+            <a:schemeClr val="accent1"/>
+          </a:effectRef>
+          <a:fontRef idx="minor">
+            <a:schemeClr val="tx1"/>
+          </a:fontRef>
+        </p:style>
+      </p:cxnSp>
+      <p:sp>
+        <p:nvSpPr>
+          <p:cNvPr id="72" name="Rectangle 71">
+            <a:extLst>
+              <a:ext uri="{FF2B5EF4-FFF2-40B4-BE49-F238E27FC236}">
+                <a16:creationId xmlns:a16="http://schemas.microsoft.com/office/drawing/2014/main" id="{85BE763E-7F01-4432-AED7-B339F21A6841}"/>
+              </a:ext>
+            </a:extLst>
+          </p:cNvPr>
+          <p:cNvSpPr/>
+          <p:nvPr/>
+        </p:nvSpPr>
+        <p:spPr>
+          <a:xfrm>
+            <a:off x="9179709" y="1095373"/>
+            <a:ext cx="2824339" cy="1330983"/>
+          </a:xfrm>
+          <a:prstGeom prst="rect">
+            <a:avLst/>
+          </a:prstGeom>
+          <a:noFill/>
+          <a:ln>
+            <a:solidFill>
+              <a:schemeClr val="tx1"/>
+            </a:solidFill>
+            <a:prstDash val="dash"/>
+          </a:ln>
+        </p:spPr>
+        <p:style>
+          <a:lnRef idx="2">
+            <a:schemeClr val="accent1">
+              <a:shade val="50000"/>
+            </a:schemeClr>
+          </a:lnRef>
+          <a:fillRef idx="1">
+            <a:schemeClr val="accent1"/>
+          </a:fillRef>
+          <a:effectRef idx="0">
+            <a:schemeClr val="accent1"/>
+          </a:effectRef>
+          <a:fontRef idx="minor">
+            <a:schemeClr val="lt1"/>
+          </a:fontRef>
+        </p:style>
+        <p:txBody>
+          <a:bodyPr rtlCol="0" anchor="ctr"/>
+          <a:lstStyle/>
+          <a:p>
+            <a:pPr algn="ctr"/>
+            <a:endParaRPr lang="de-CH"/>
+          </a:p>
+        </p:txBody>
+      </p:sp>
+      <p:sp>
+        <p:nvSpPr>
+          <p:cNvPr id="73" name="TextBox 72">
+            <a:extLst>
+              <a:ext uri="{FF2B5EF4-FFF2-40B4-BE49-F238E27FC236}">
+                <a16:creationId xmlns:a16="http://schemas.microsoft.com/office/drawing/2014/main" id="{EC424C64-8A18-43DA-8B53-15ACF8A0939B}"/>
+              </a:ext>
+            </a:extLst>
+          </p:cNvPr>
+          <p:cNvSpPr txBox="1"/>
+          <p:nvPr/>
+        </p:nvSpPr>
+        <p:spPr>
+          <a:xfrm>
+            <a:off x="10059584" y="668529"/>
+            <a:ext cx="1401089" cy="369332"/>
+          </a:xfrm>
+          <a:prstGeom prst="rect">
+            <a:avLst/>
+          </a:prstGeom>
+          <a:noFill/>
+        </p:spPr>
+        <p:txBody>
+          <a:bodyPr wrap="none" rtlCol="0">
+            <a:spAutoFit/>
+          </a:bodyPr>
+          <a:lstStyle/>
+          <a:p>
+            <a:r>
+              <a:rPr lang="de-CH" b="1" dirty="0" err="1"/>
+              <a:t>Visualization</a:t>
+            </a:r>
+            <a:endParaRPr lang="de-CH" b="1" dirty="0"/>
+          </a:p>
+        </p:txBody>
+      </p:sp>
+      <p:cxnSp>
+        <p:nvCxnSpPr>
+          <p:cNvPr id="76" name="Straight Arrow Connector 75">
+            <a:extLst>
+              <a:ext uri="{FF2B5EF4-FFF2-40B4-BE49-F238E27FC236}">
+                <a16:creationId xmlns:a16="http://schemas.microsoft.com/office/drawing/2014/main" id="{6FD7300A-81CE-456B-A888-8F5826F3EE4E}"/>
+              </a:ext>
+            </a:extLst>
+          </p:cNvPr>
+          <p:cNvCxnSpPr>
+            <a:cxnSpLocks/>
+            <a:stCxn id="65" idx="0"/>
+            <a:endCxn id="72" idx="2"/>
+          </p:cNvCxnSpPr>
+          <p:nvPr/>
+        </p:nvCxnSpPr>
+        <p:spPr>
+          <a:xfrm flipH="1" flipV="1">
+            <a:off x="10591879" y="2426356"/>
+            <a:ext cx="13319" cy="895845"/>
+          </a:xfrm>
+          <a:prstGeom prst="straightConnector1">
+            <a:avLst/>
+          </a:prstGeom>
+          <a:ln>
+            <a:tailEnd type="triangle"/>
+          </a:ln>
+        </p:spPr>
+        <p:style>
+          <a:lnRef idx="1">
+            <a:schemeClr val="accent1"/>
+          </a:lnRef>
+          <a:fillRef idx="0">
+            <a:schemeClr val="accent1"/>
+          </a:fillRef>
+          <a:effectRef idx="0">
+            <a:schemeClr val="accent1"/>
+          </a:effectRef>
+          <a:fontRef idx="minor">
+            <a:schemeClr val="tx1"/>
+          </a:fontRef>
+        </p:style>
+      </p:cxnSp>
+      <p:pic>
+        <p:nvPicPr>
+          <p:cNvPr id="80" name="Picture 79">
+            <a:extLst>
+              <a:ext uri="{FF2B5EF4-FFF2-40B4-BE49-F238E27FC236}">
+                <a16:creationId xmlns:a16="http://schemas.microsoft.com/office/drawing/2014/main" id="{79B2CDE4-9028-47EB-998B-703CBF515CD0}"/>
+              </a:ext>
+            </a:extLst>
+          </p:cNvPr>
+          <p:cNvPicPr>
+            <a:picLocks noChangeAspect="1"/>
+          </p:cNvPicPr>
+          <p:nvPr/>
+        </p:nvPicPr>
+        <p:blipFill>
+          <a:blip r:embed="rId7"/>
+          <a:stretch>
+            <a:fillRect/>
+          </a:stretch>
+        </p:blipFill>
+        <p:spPr>
+          <a:xfrm>
+            <a:off x="9287446" y="1010471"/>
+            <a:ext cx="2653335" cy="1448608"/>
+          </a:xfrm>
+          <a:prstGeom prst="rect">
+            <a:avLst/>
+          </a:prstGeom>
+        </p:spPr>
+      </p:pic>
+      <p:pic>
+        <p:nvPicPr>
+          <p:cNvPr id="82" name="Picture 81">
+            <a:extLst>
+              <a:ext uri="{FF2B5EF4-FFF2-40B4-BE49-F238E27FC236}">
+                <a16:creationId xmlns:a16="http://schemas.microsoft.com/office/drawing/2014/main" id="{61011012-DECE-4E86-88B7-A78883B6E08F}"/>
+              </a:ext>
+            </a:extLst>
+          </p:cNvPr>
+          <p:cNvPicPr>
+            <a:picLocks noChangeAspect="1"/>
+          </p:cNvPicPr>
+          <p:nvPr/>
+        </p:nvPicPr>
+        <p:blipFill>
+          <a:blip r:embed="rId8">
+            <a:extLst>
+              <a:ext uri="{28A0092B-C50C-407E-A947-70E740481C1C}">
+                <a14:useLocalDpi xmlns:a14="http://schemas.microsoft.com/office/drawing/2010/main" val="0"/>
+              </a:ext>
+            </a:extLst>
+          </a:blip>
+          <a:stretch>
+            <a:fillRect/>
+          </a:stretch>
+        </p:blipFill>
+        <p:spPr>
+          <a:xfrm>
+            <a:off x="10688889" y="38049"/>
+            <a:ext cx="1081452" cy="632965"/>
+          </a:xfrm>
+          <a:prstGeom prst="rect">
+            <a:avLst/>
+          </a:prstGeom>
+        </p:spPr>
+      </p:pic>
+      <p:pic>
+        <p:nvPicPr>
+          <p:cNvPr id="84" name="Picture 83">
+            <a:extLst>
+              <a:ext uri="{FF2B5EF4-FFF2-40B4-BE49-F238E27FC236}">
+                <a16:creationId xmlns:a16="http://schemas.microsoft.com/office/drawing/2014/main" id="{016BFE71-80AC-494E-85D4-F39F74B4384B}"/>
+              </a:ext>
+            </a:extLst>
+          </p:cNvPr>
+          <p:cNvPicPr>
+            <a:picLocks noChangeAspect="1"/>
+          </p:cNvPicPr>
+          <p:nvPr/>
+        </p:nvPicPr>
+        <p:blipFill>
+          <a:blip r:embed="rId9">
+            <a:extLst>
+              <a:ext uri="{28A0092B-C50C-407E-A947-70E740481C1C}">
+                <a14:useLocalDpi xmlns:a14="http://schemas.microsoft.com/office/drawing/2010/main" val="0"/>
+              </a:ext>
+            </a:extLst>
+          </a:blip>
+          <a:stretch>
+            <a:fillRect/>
+          </a:stretch>
+        </p:blipFill>
+        <p:spPr>
+          <a:xfrm>
+            <a:off x="9202788" y="151963"/>
+            <a:ext cx="1497739" cy="512441"/>
+          </a:xfrm>
+          <a:prstGeom prst="rect">
+            <a:avLst/>
+          </a:prstGeom>
+        </p:spPr>
+      </p:pic>
+      <p:pic>
+        <p:nvPicPr>
+          <p:cNvPr id="85" name="Picture 84">
+            <a:extLst>
+              <a:ext uri="{FF2B5EF4-FFF2-40B4-BE49-F238E27FC236}">
+                <a16:creationId xmlns:a16="http://schemas.microsoft.com/office/drawing/2014/main" id="{AE23BBE3-843F-4FD2-92C4-24855B47BF05}"/>
+              </a:ext>
+            </a:extLst>
+          </p:cNvPr>
+          <p:cNvPicPr>
+            <a:picLocks noChangeAspect="1"/>
+          </p:cNvPicPr>
+          <p:nvPr/>
+        </p:nvPicPr>
+        <p:blipFill>
+          <a:blip r:embed="rId6">
+            <a:extLst>
+              <a:ext uri="{28A0092B-C50C-407E-A947-70E740481C1C}">
+                <a14:useLocalDpi xmlns:a14="http://schemas.microsoft.com/office/drawing/2010/main" val="0"/>
+              </a:ext>
+            </a:extLst>
+          </a:blip>
+          <a:stretch>
+            <a:fillRect/>
+          </a:stretch>
+        </p:blipFill>
+        <p:spPr>
+          <a:xfrm>
+            <a:off x="11817518" y="408183"/>
+            <a:ext cx="393022" cy="393022"/>
+          </a:xfrm>
+          <a:prstGeom prst="rect">
+            <a:avLst/>
+          </a:prstGeom>
+        </p:spPr>
+      </p:pic>
+      <p:sp>
+        <p:nvSpPr>
+          <p:cNvPr id="86" name="Rectangle 85">
+            <a:extLst>
+              <a:ext uri="{FF2B5EF4-FFF2-40B4-BE49-F238E27FC236}">
+                <a16:creationId xmlns:a16="http://schemas.microsoft.com/office/drawing/2014/main" id="{792D895E-16AA-4ECD-AA8C-54C768871F3A}"/>
+              </a:ext>
+            </a:extLst>
+          </p:cNvPr>
+          <p:cNvSpPr/>
+          <p:nvPr/>
+        </p:nvSpPr>
+        <p:spPr>
+          <a:xfrm>
+            <a:off x="9664882" y="3969097"/>
+            <a:ext cx="2339166" cy="2501914"/>
+          </a:xfrm>
+          <a:prstGeom prst="rect">
+            <a:avLst/>
+          </a:prstGeom>
+          <a:noFill/>
+          <a:ln>
+            <a:solidFill>
+              <a:schemeClr val="tx1"/>
+            </a:solidFill>
+            <a:prstDash val="dash"/>
+          </a:ln>
+        </p:spPr>
+        <p:style>
+          <a:lnRef idx="2">
+            <a:schemeClr val="accent1">
+              <a:shade val="50000"/>
+            </a:schemeClr>
+          </a:lnRef>
+          <a:fillRef idx="1">
+            <a:schemeClr val="accent1"/>
+          </a:fillRef>
+          <a:effectRef idx="0">
+            <a:schemeClr val="accent1"/>
+          </a:effectRef>
+          <a:fontRef idx="minor">
+            <a:schemeClr val="lt1"/>
+          </a:fontRef>
+        </p:style>
+        <p:txBody>
+          <a:bodyPr rtlCol="0" anchor="ctr"/>
+          <a:lstStyle/>
+          <a:p>
+            <a:pPr algn="ctr"/>
+            <a:endParaRPr lang="de-CH"/>
+          </a:p>
+        </p:txBody>
+      </p:sp>
+      <p:sp>
+        <p:nvSpPr>
+          <p:cNvPr id="18" name="Rectangle 17">
+            <a:extLst>
+              <a:ext uri="{FF2B5EF4-FFF2-40B4-BE49-F238E27FC236}">
+                <a16:creationId xmlns:a16="http://schemas.microsoft.com/office/drawing/2014/main" id="{CCB8C28A-8AF0-4F74-8F80-7DFE3F26DDA6}"/>
+              </a:ext>
+            </a:extLst>
+          </p:cNvPr>
+          <p:cNvSpPr/>
+          <p:nvPr/>
+        </p:nvSpPr>
+        <p:spPr>
+          <a:xfrm>
+            <a:off x="118659" y="4271765"/>
+            <a:ext cx="1320307" cy="461665"/>
+          </a:xfrm>
+          <a:prstGeom prst="rect">
+            <a:avLst/>
+          </a:prstGeom>
+        </p:spPr>
+        <p:txBody>
+          <a:bodyPr wrap="square">
+            <a:spAutoFit/>
+          </a:bodyPr>
+          <a:lstStyle/>
+          <a:p>
+            <a:r>
+              <a:rPr lang="de-CH" sz="1200" dirty="0" err="1"/>
+              <a:t>Statistic</a:t>
+            </a:r>
+            <a:r>
+              <a:rPr lang="de-CH" sz="1200" dirty="0"/>
+              <a:t> Times</a:t>
+            </a:r>
+            <a:br>
+              <a:rPr lang="de-CH" sz="1200" dirty="0"/>
+            </a:br>
+            <a:r>
+              <a:rPr lang="de-CH" sz="1200" dirty="0"/>
+              <a:t>INCED</a:t>
+            </a:r>
+          </a:p>
+        </p:txBody>
+      </p:sp>
+      <p:sp>
+        <p:nvSpPr>
+          <p:cNvPr id="57" name="TextBox 56">
+            <a:extLst>
+              <a:ext uri="{FF2B5EF4-FFF2-40B4-BE49-F238E27FC236}">
+                <a16:creationId xmlns:a16="http://schemas.microsoft.com/office/drawing/2014/main" id="{68973681-C79F-408C-8B78-B559E7D4B5D3}"/>
+              </a:ext>
+            </a:extLst>
+          </p:cNvPr>
+          <p:cNvSpPr txBox="1"/>
+          <p:nvPr/>
+        </p:nvSpPr>
+        <p:spPr>
+          <a:xfrm>
+            <a:off x="3923386" y="1562763"/>
+            <a:ext cx="1140056" cy="369332"/>
+          </a:xfrm>
+          <a:prstGeom prst="rect">
+            <a:avLst/>
+          </a:prstGeom>
+          <a:noFill/>
+        </p:spPr>
+        <p:txBody>
+          <a:bodyPr wrap="none" rtlCol="0">
+            <a:spAutoFit/>
+          </a:bodyPr>
+          <a:lstStyle/>
+          <a:p>
+            <a:r>
+              <a:rPr lang="de-CH" dirty="0" err="1"/>
+              <a:t>Html_files</a:t>
+            </a:r>
+            <a:endParaRPr lang="de-CH" dirty="0"/>
+          </a:p>
+        </p:txBody>
+      </p:sp>
+      <p:sp>
+        <p:nvSpPr>
+          <p:cNvPr id="67" name="TextBox 66">
+            <a:extLst>
+              <a:ext uri="{FF2B5EF4-FFF2-40B4-BE49-F238E27FC236}">
+                <a16:creationId xmlns:a16="http://schemas.microsoft.com/office/drawing/2014/main" id="{5B2DEE84-9E18-4828-919F-7CDB40AEBB64}"/>
+              </a:ext>
+            </a:extLst>
+          </p:cNvPr>
+          <p:cNvSpPr txBox="1"/>
+          <p:nvPr/>
+        </p:nvSpPr>
+        <p:spPr>
+          <a:xfrm>
+            <a:off x="3967036" y="1800889"/>
+            <a:ext cx="986873" cy="369332"/>
+          </a:xfrm>
+          <a:prstGeom prst="rect">
+            <a:avLst/>
+          </a:prstGeom>
+          <a:noFill/>
+        </p:spPr>
+        <p:txBody>
+          <a:bodyPr wrap="none" rtlCol="0">
+            <a:spAutoFit/>
+          </a:bodyPr>
+          <a:lstStyle/>
+          <a:p>
+            <a:r>
+              <a:rPr lang="de-CH" i="1" dirty="0" err="1"/>
+              <a:t>Csv_files</a:t>
+            </a:r>
+            <a:endParaRPr lang="de-CH" i="1" dirty="0"/>
+          </a:p>
+        </p:txBody>
+      </p:sp>
+      <p:sp>
+        <p:nvSpPr>
+          <p:cNvPr id="68" name="TextBox 67">
+            <a:extLst>
+              <a:ext uri="{FF2B5EF4-FFF2-40B4-BE49-F238E27FC236}">
+                <a16:creationId xmlns:a16="http://schemas.microsoft.com/office/drawing/2014/main" id="{35326C4A-DB77-4C2B-A7FF-C41518AD5296}"/>
+              </a:ext>
+            </a:extLst>
+          </p:cNvPr>
+          <p:cNvSpPr txBox="1"/>
+          <p:nvPr/>
+        </p:nvSpPr>
+        <p:spPr>
+          <a:xfrm>
+            <a:off x="4049783" y="2725698"/>
+            <a:ext cx="1140056" cy="369332"/>
+          </a:xfrm>
+          <a:prstGeom prst="rect">
+            <a:avLst/>
+          </a:prstGeom>
+          <a:noFill/>
+        </p:spPr>
+        <p:txBody>
+          <a:bodyPr wrap="none" rtlCol="0">
+            <a:spAutoFit/>
+          </a:bodyPr>
+          <a:lstStyle/>
+          <a:p>
+            <a:r>
+              <a:rPr lang="de-CH" dirty="0" err="1"/>
+              <a:t>Html_files</a:t>
+            </a:r>
+            <a:endParaRPr lang="de-CH" dirty="0"/>
+          </a:p>
+        </p:txBody>
+      </p:sp>
+      <p:sp>
+        <p:nvSpPr>
+          <p:cNvPr id="70" name="TextBox 69">
+            <a:extLst>
+              <a:ext uri="{FF2B5EF4-FFF2-40B4-BE49-F238E27FC236}">
+                <a16:creationId xmlns:a16="http://schemas.microsoft.com/office/drawing/2014/main" id="{132AEB53-4E22-40A1-BE45-887D9D439445}"/>
+              </a:ext>
+            </a:extLst>
+          </p:cNvPr>
+          <p:cNvSpPr txBox="1"/>
+          <p:nvPr/>
+        </p:nvSpPr>
+        <p:spPr>
+          <a:xfrm>
+            <a:off x="4093433" y="2963824"/>
+            <a:ext cx="986873" cy="369332"/>
+          </a:xfrm>
+          <a:prstGeom prst="rect">
+            <a:avLst/>
+          </a:prstGeom>
+          <a:noFill/>
+        </p:spPr>
+        <p:txBody>
+          <a:bodyPr wrap="none" rtlCol="0">
+            <a:spAutoFit/>
+          </a:bodyPr>
+          <a:lstStyle/>
+          <a:p>
+            <a:r>
+              <a:rPr lang="de-CH" i="1" dirty="0" err="1"/>
+              <a:t>Csv_files</a:t>
+            </a:r>
+            <a:endParaRPr lang="de-CH" i="1" dirty="0"/>
+          </a:p>
+        </p:txBody>
+      </p:sp>
+      <p:sp>
+        <p:nvSpPr>
+          <p:cNvPr id="71" name="TextBox 70">
+            <a:extLst>
+              <a:ext uri="{FF2B5EF4-FFF2-40B4-BE49-F238E27FC236}">
+                <a16:creationId xmlns:a16="http://schemas.microsoft.com/office/drawing/2014/main" id="{2F732659-9B7D-44A4-8273-F8FD9C3327F7}"/>
+              </a:ext>
+            </a:extLst>
+          </p:cNvPr>
+          <p:cNvSpPr txBox="1"/>
+          <p:nvPr/>
+        </p:nvSpPr>
+        <p:spPr>
+          <a:xfrm>
+            <a:off x="4101227" y="4182973"/>
+            <a:ext cx="1140056" cy="369332"/>
+          </a:xfrm>
+          <a:prstGeom prst="rect">
+            <a:avLst/>
+          </a:prstGeom>
+          <a:noFill/>
+        </p:spPr>
+        <p:txBody>
+          <a:bodyPr wrap="none" rtlCol="0">
+            <a:spAutoFit/>
+          </a:bodyPr>
+          <a:lstStyle/>
+          <a:p>
+            <a:r>
+              <a:rPr lang="de-CH" dirty="0" err="1"/>
+              <a:t>Html_files</a:t>
+            </a:r>
+            <a:endParaRPr lang="de-CH" dirty="0"/>
+          </a:p>
+        </p:txBody>
+      </p:sp>
+      <p:sp>
+        <p:nvSpPr>
+          <p:cNvPr id="74" name="TextBox 73">
+            <a:extLst>
+              <a:ext uri="{FF2B5EF4-FFF2-40B4-BE49-F238E27FC236}">
+                <a16:creationId xmlns:a16="http://schemas.microsoft.com/office/drawing/2014/main" id="{9CD15625-025B-430C-9C17-4D660BFD0964}"/>
+              </a:ext>
+            </a:extLst>
+          </p:cNvPr>
+          <p:cNvSpPr txBox="1"/>
+          <p:nvPr/>
+        </p:nvSpPr>
+        <p:spPr>
+          <a:xfrm>
+            <a:off x="3516899" y="4493769"/>
+            <a:ext cx="1490729" cy="369332"/>
+          </a:xfrm>
+          <a:prstGeom prst="rect">
+            <a:avLst/>
+          </a:prstGeom>
+          <a:noFill/>
+        </p:spPr>
+        <p:txBody>
+          <a:bodyPr wrap="none" rtlCol="0">
+            <a:spAutoFit/>
+          </a:bodyPr>
+          <a:lstStyle/>
+          <a:p>
+            <a:r>
+              <a:rPr lang="de-CH" i="1" dirty="0"/>
+              <a:t>JPGs </a:t>
+            </a:r>
+            <a:r>
+              <a:rPr lang="de-CH" i="1" dirty="0" err="1"/>
+              <a:t>of</a:t>
+            </a:r>
+            <a:r>
+              <a:rPr lang="de-CH" i="1" dirty="0"/>
+              <a:t> </a:t>
+            </a:r>
+            <a:r>
+              <a:rPr lang="de-CH" i="1" dirty="0" err="1"/>
+              <a:t>Tables</a:t>
+            </a:r>
+            <a:endParaRPr lang="de-CH" i="1" dirty="0"/>
+          </a:p>
+        </p:txBody>
+      </p:sp>
+      <p:sp>
+        <p:nvSpPr>
+          <p:cNvPr id="75" name="TextBox 74">
+            <a:extLst>
+              <a:ext uri="{FF2B5EF4-FFF2-40B4-BE49-F238E27FC236}">
+                <a16:creationId xmlns:a16="http://schemas.microsoft.com/office/drawing/2014/main" id="{A9584F5C-2EBC-4CFB-9853-5669D321423C}"/>
+              </a:ext>
+            </a:extLst>
+          </p:cNvPr>
+          <p:cNvSpPr txBox="1"/>
+          <p:nvPr/>
+        </p:nvSpPr>
+        <p:spPr>
+          <a:xfrm>
+            <a:off x="3791782" y="5404474"/>
+            <a:ext cx="1571264" cy="369332"/>
+          </a:xfrm>
+          <a:prstGeom prst="rect">
+            <a:avLst/>
+          </a:prstGeom>
+          <a:noFill/>
+        </p:spPr>
+        <p:txBody>
+          <a:bodyPr wrap="none" rtlCol="0">
+            <a:spAutoFit/>
+          </a:bodyPr>
+          <a:lstStyle/>
+          <a:p>
+            <a:r>
+              <a:rPr lang="de-CH" dirty="0" err="1"/>
+              <a:t>Geo</a:t>
+            </a:r>
+            <a:r>
+              <a:rPr lang="de-CH" dirty="0"/>
+              <a:t> JSON Files</a:t>
+            </a:r>
+          </a:p>
+        </p:txBody>
+      </p:sp>
+      <p:sp>
+        <p:nvSpPr>
+          <p:cNvPr id="78" name="TextBox 77">
+            <a:extLst>
+              <a:ext uri="{FF2B5EF4-FFF2-40B4-BE49-F238E27FC236}">
+                <a16:creationId xmlns:a16="http://schemas.microsoft.com/office/drawing/2014/main" id="{0FA12E35-6A6C-4A0F-B080-71A2B1ABD09E}"/>
+              </a:ext>
+            </a:extLst>
+          </p:cNvPr>
+          <p:cNvSpPr txBox="1"/>
+          <p:nvPr/>
+        </p:nvSpPr>
+        <p:spPr>
+          <a:xfrm>
+            <a:off x="5208576" y="4486702"/>
+            <a:ext cx="649152" cy="369332"/>
+          </a:xfrm>
+          <a:prstGeom prst="rect">
+            <a:avLst/>
+          </a:prstGeom>
+          <a:noFill/>
+        </p:spPr>
+        <p:txBody>
+          <a:bodyPr wrap="none" rtlCol="0">
+            <a:spAutoFit/>
+          </a:bodyPr>
+          <a:lstStyle/>
+          <a:p>
+            <a:r>
+              <a:rPr lang="de-CH" i="1" dirty="0"/>
+              <a:t>Excel</a:t>
+            </a:r>
+          </a:p>
+        </p:txBody>
+      </p:sp>
+      <p:pic>
+        <p:nvPicPr>
+          <p:cNvPr id="1026" name="Picture 2" descr="Datei:Microsoft Office Excel (2019–present).svg – Wikipedia">
+            <a:hlinkClick r:id="rId10"/>
+            <a:extLst>
+              <a:ext uri="{FF2B5EF4-FFF2-40B4-BE49-F238E27FC236}">
+                <a16:creationId xmlns:a16="http://schemas.microsoft.com/office/drawing/2014/main" id="{4729707E-F5BD-4F98-A07B-07BF0B897F46}"/>
+              </a:ext>
+            </a:extLst>
+          </p:cNvPr>
+          <p:cNvPicPr>
+            <a:picLocks noChangeAspect="1" noChangeArrowheads="1"/>
+          </p:cNvPicPr>
+          <p:nvPr/>
+        </p:nvPicPr>
+        <p:blipFill>
+          <a:blip r:embed="rId11">
+            <a:extLst>
+              <a:ext uri="{28A0092B-C50C-407E-A947-70E740481C1C}">
+                <a14:useLocalDpi xmlns:a14="http://schemas.microsoft.com/office/drawing/2010/main" val="0"/>
+              </a:ext>
+            </a:extLst>
+          </a:blip>
+          <a:srcRect/>
+          <a:stretch>
+            <a:fillRect/>
+          </a:stretch>
+        </p:blipFill>
+        <p:spPr bwMode="auto">
+          <a:xfrm>
+            <a:off x="5562891" y="6106480"/>
+            <a:ext cx="777860" cy="724444"/>
+          </a:xfrm>
+          <a:prstGeom prst="rect">
+            <a:avLst/>
+          </a:prstGeom>
+          <a:noFill/>
+          <a:extLst>
+            <a:ext uri="{909E8E84-426E-40DD-AFC4-6F175D3DCCD1}">
+              <a14:hiddenFill xmlns:a14="http://schemas.microsoft.com/office/drawing/2010/main">
+                <a:solidFill>
+                  <a:srgbClr val="FFFFFF"/>
+                </a:solidFill>
+              </a14:hiddenFill>
+            </a:ext>
+          </a:extLst>
+        </p:spPr>
+      </p:pic>
+      <p:pic>
+        <p:nvPicPr>
+          <p:cNvPr id="25" name="Picture 24">
+            <a:extLst>
+              <a:ext uri="{FF2B5EF4-FFF2-40B4-BE49-F238E27FC236}">
+                <a16:creationId xmlns:a16="http://schemas.microsoft.com/office/drawing/2014/main" id="{98BB948E-446A-41FD-A1B4-327456CA9AF3}"/>
+              </a:ext>
+            </a:extLst>
+          </p:cNvPr>
+          <p:cNvPicPr>
+            <a:picLocks noChangeAspect="1"/>
+          </p:cNvPicPr>
+          <p:nvPr/>
+        </p:nvPicPr>
+        <p:blipFill>
+          <a:blip r:embed="rId12"/>
+          <a:stretch>
+            <a:fillRect/>
+          </a:stretch>
+        </p:blipFill>
+        <p:spPr>
+          <a:xfrm>
+            <a:off x="4469065" y="6088896"/>
+            <a:ext cx="1286037" cy="189258"/>
+          </a:xfrm>
+          <a:prstGeom prst="rect">
+            <a:avLst/>
+          </a:prstGeom>
+        </p:spPr>
+      </p:pic>
     </p:spTree>
     <p:extLst>
       <p:ext uri="{BB962C8B-B14F-4D97-AF65-F5344CB8AC3E}">
@@ -12676,6 +15826,45 @@
                 </a:solidFill>
               </a:rPr>
               <a:t>Markers</a:t>
+            </a:r>
+          </a:p>
+        </p:txBody>
+      </p:sp>
+      <p:sp>
+        <p:nvSpPr>
+          <p:cNvPr id="17" name="TextBox 16">
+            <a:extLst>
+              <a:ext uri="{FF2B5EF4-FFF2-40B4-BE49-F238E27FC236}">
+                <a16:creationId xmlns:a16="http://schemas.microsoft.com/office/drawing/2014/main" id="{BB5FBE32-7EDC-4C3C-9432-B4B984EB1002}"/>
+              </a:ext>
+            </a:extLst>
+          </p:cNvPr>
+          <p:cNvSpPr txBox="1"/>
+          <p:nvPr/>
+        </p:nvSpPr>
+        <p:spPr>
+          <a:xfrm>
+            <a:off x="7225256" y="5064490"/>
+            <a:ext cx="2033762" cy="369332"/>
+          </a:xfrm>
+          <a:prstGeom prst="rect">
+            <a:avLst/>
+          </a:prstGeom>
+          <a:noFill/>
+        </p:spPr>
+        <p:txBody>
+          <a:bodyPr wrap="none" rtlCol="0">
+            <a:spAutoFit/>
+          </a:bodyPr>
+          <a:lstStyle/>
+          <a:p>
+            <a:r>
+              <a:rPr lang="de-CH" dirty="0">
+                <a:solidFill>
+                  <a:schemeClr val="bg1"/>
+                </a:solidFill>
+              </a:rPr>
+              <a:t>Colors = Companies</a:t>
             </a:r>
           </a:p>
         </p:txBody>
@@ -12986,4 +16175,299 @@
     </a:ext>
   </a:extLst>
 </a:theme>
+</file>
+
+<file path=ppt/theme/theme2.xml><?xml version="1.0" encoding="utf-8"?>
+<a:theme xmlns:a="http://schemas.openxmlformats.org/drawingml/2006/main" name="Office Theme">
+  <a:themeElements>
+    <a:clrScheme name="Office">
+      <a:dk1>
+        <a:sysClr val="windowText" lastClr="000000"/>
+      </a:dk1>
+      <a:lt1>
+        <a:sysClr val="window" lastClr="FFFFFF"/>
+      </a:lt1>
+      <a:dk2>
+        <a:srgbClr val="44546A"/>
+      </a:dk2>
+      <a:lt2>
+        <a:srgbClr val="E7E6E6"/>
+      </a:lt2>
+      <a:accent1>
+        <a:srgbClr val="4472C4"/>
+      </a:accent1>
+      <a:accent2>
+        <a:srgbClr val="ED7D31"/>
+      </a:accent2>
+      <a:accent3>
+        <a:srgbClr val="A5A5A5"/>
+      </a:accent3>
+      <a:accent4>
+        <a:srgbClr val="FFC000"/>
+      </a:accent4>
+      <a:accent5>
+        <a:srgbClr val="5B9BD5"/>
+      </a:accent5>
+      <a:accent6>
+        <a:srgbClr val="70AD47"/>
+      </a:accent6>
+      <a:hlink>
+        <a:srgbClr val="0563C1"/>
+      </a:hlink>
+      <a:folHlink>
+        <a:srgbClr val="954F72"/>
+      </a:folHlink>
+    </a:clrScheme>
+    <a:fontScheme name="Office">
+      <a:majorFont>
+        <a:latin typeface="Calibri Light" panose="020F0302020204030204"/>
+        <a:ea typeface=""/>
+        <a:cs typeface=""/>
+        <a:font script="Jpan" typeface="游ゴシック Light"/>
+        <a:font script="Hang" typeface="맑은 고딕"/>
+        <a:font script="Hans" typeface="等线 Light"/>
+        <a:font script="Hant" typeface="新細明體"/>
+        <a:font script="Arab" typeface="Times New Roman"/>
+        <a:font script="Hebr" typeface="Times New Roman"/>
+        <a:font script="Thai" typeface="Angsana New"/>
+        <a:font script="Ethi" typeface="Nyala"/>
+        <a:font script="Beng" typeface="Vrinda"/>
+        <a:font script="Gujr" typeface="Shruti"/>
+        <a:font script="Khmr" typeface="MoolBoran"/>
+        <a:font script="Knda" typeface="Tunga"/>
+        <a:font script="Guru" typeface="Raavi"/>
+        <a:font script="Cans" typeface="Euphemia"/>
+        <a:font script="Cher" typeface="Plantagenet Cherokee"/>
+        <a:font script="Yiii" typeface="Microsoft Yi Baiti"/>
+        <a:font script="Tibt" typeface="Microsoft Himalaya"/>
+        <a:font script="Thaa" typeface="MV Boli"/>
+        <a:font script="Deva" typeface="Mangal"/>
+        <a:font script="Telu" typeface="Gautami"/>
+        <a:font script="Taml" typeface="Latha"/>
+        <a:font script="Syrc" typeface="Estrangelo Edessa"/>
+        <a:font script="Orya" typeface="Kalinga"/>
+        <a:font script="Mlym" typeface="Kartika"/>
+        <a:font script="Laoo" typeface="DokChampa"/>
+        <a:font script="Sinh" typeface="Iskoola Pota"/>
+        <a:font script="Mong" typeface="Mongolian Baiti"/>
+        <a:font script="Viet" typeface="Times New Roman"/>
+        <a:font script="Uigh" typeface="Microsoft Uighur"/>
+        <a:font script="Geor" typeface="Sylfaen"/>
+        <a:font script="Armn" typeface="Arial"/>
+        <a:font script="Bugi" typeface="Leelawadee UI"/>
+        <a:font script="Bopo" typeface="Microsoft JhengHei"/>
+        <a:font script="Java" typeface="Javanese Text"/>
+        <a:font script="Lisu" typeface="Segoe UI"/>
+        <a:font script="Mymr" typeface="Myanmar Text"/>
+        <a:font script="Nkoo" typeface="Ebrima"/>
+        <a:font script="Olck" typeface="Nirmala UI"/>
+        <a:font script="Osma" typeface="Ebrima"/>
+        <a:font script="Phag" typeface="Phagspa"/>
+        <a:font script="Syrn" typeface="Estrangelo Edessa"/>
+        <a:font script="Syrj" typeface="Estrangelo Edessa"/>
+        <a:font script="Syre" typeface="Estrangelo Edessa"/>
+        <a:font script="Sora" typeface="Nirmala UI"/>
+        <a:font script="Tale" typeface="Microsoft Tai Le"/>
+        <a:font script="Talu" typeface="Microsoft New Tai Lue"/>
+        <a:font script="Tfng" typeface="Ebrima"/>
+      </a:majorFont>
+      <a:minorFont>
+        <a:latin typeface="Calibri" panose="020F0502020204030204"/>
+        <a:ea typeface=""/>
+        <a:cs typeface=""/>
+        <a:font script="Jpan" typeface="游ゴシック"/>
+        <a:font script="Hang" typeface="맑은 고딕"/>
+        <a:font script="Hans" typeface="等线"/>
+        <a:font script="Hant" typeface="新細明體"/>
+        <a:font script="Arab" typeface="Arial"/>
+        <a:font script="Hebr" typeface="Arial"/>
+        <a:font script="Thai" typeface="Cordia New"/>
+        <a:font script="Ethi" typeface="Nyala"/>
+        <a:font script="Beng" typeface="Vrinda"/>
+        <a:font script="Gujr" typeface="Shruti"/>
+        <a:font script="Khmr" typeface="DaunPenh"/>
+        <a:font script="Knda" typeface="Tunga"/>
+        <a:font script="Guru" typeface="Raavi"/>
+        <a:font script="Cans" typeface="Euphemia"/>
+        <a:font script="Cher" typeface="Plantagenet Cherokee"/>
+        <a:font script="Yiii" typeface="Microsoft Yi Baiti"/>
+        <a:font script="Tibt" typeface="Microsoft Himalaya"/>
+        <a:font script="Thaa" typeface="MV Boli"/>
+        <a:font script="Deva" typeface="Mangal"/>
+        <a:font script="Telu" typeface="Gautami"/>
+        <a:font script="Taml" typeface="Latha"/>
+        <a:font script="Syrc" typeface="Estrangelo Edessa"/>
+        <a:font script="Orya" typeface="Kalinga"/>
+        <a:font script="Mlym" typeface="Kartika"/>
+        <a:font script="Laoo" typeface="DokChampa"/>
+        <a:font script="Sinh" typeface="Iskoola Pota"/>
+        <a:font script="Mong" typeface="Mongolian Baiti"/>
+        <a:font script="Viet" typeface="Arial"/>
+        <a:font script="Uigh" typeface="Microsoft Uighur"/>
+        <a:font script="Geor" typeface="Sylfaen"/>
+        <a:font script="Armn" typeface="Arial"/>
+        <a:font script="Bugi" typeface="Leelawadee UI"/>
+        <a:font script="Bopo" typeface="Microsoft JhengHei"/>
+        <a:font script="Java" typeface="Javanese Text"/>
+        <a:font script="Lisu" typeface="Segoe UI"/>
+        <a:font script="Mymr" typeface="Myanmar Text"/>
+        <a:font script="Nkoo" typeface="Ebrima"/>
+        <a:font script="Olck" typeface="Nirmala UI"/>
+        <a:font script="Osma" typeface="Ebrima"/>
+        <a:font script="Phag" typeface="Phagspa"/>
+        <a:font script="Syrn" typeface="Estrangelo Edessa"/>
+        <a:font script="Syrj" typeface="Estrangelo Edessa"/>
+        <a:font script="Syre" typeface="Estrangelo Edessa"/>
+        <a:font script="Sora" typeface="Nirmala UI"/>
+        <a:font script="Tale" typeface="Microsoft Tai Le"/>
+        <a:font script="Talu" typeface="Microsoft New Tai Lue"/>
+        <a:font script="Tfng" typeface="Ebrima"/>
+      </a:minorFont>
+    </a:fontScheme>
+    <a:fmtScheme name="Office">
+      <a:fillStyleLst>
+        <a:solidFill>
+          <a:schemeClr val="phClr"/>
+        </a:solidFill>
+        <a:gradFill rotWithShape="1">
+          <a:gsLst>
+            <a:gs pos="0">
+              <a:schemeClr val="phClr">
+                <a:lumMod val="110000"/>
+                <a:satMod val="105000"/>
+                <a:tint val="67000"/>
+              </a:schemeClr>
+            </a:gs>
+            <a:gs pos="50000">
+              <a:schemeClr val="phClr">
+                <a:lumMod val="105000"/>
+                <a:satMod val="103000"/>
+                <a:tint val="73000"/>
+              </a:schemeClr>
+            </a:gs>
+            <a:gs pos="100000">
+              <a:schemeClr val="phClr">
+                <a:lumMod val="105000"/>
+                <a:satMod val="109000"/>
+                <a:tint val="81000"/>
+              </a:schemeClr>
+            </a:gs>
+          </a:gsLst>
+          <a:lin ang="5400000" scaled="0"/>
+        </a:gradFill>
+        <a:gradFill rotWithShape="1">
+          <a:gsLst>
+            <a:gs pos="0">
+              <a:schemeClr val="phClr">
+                <a:satMod val="103000"/>
+                <a:lumMod val="102000"/>
+                <a:tint val="94000"/>
+              </a:schemeClr>
+            </a:gs>
+            <a:gs pos="50000">
+              <a:schemeClr val="phClr">
+                <a:satMod val="110000"/>
+                <a:lumMod val="100000"/>
+                <a:shade val="100000"/>
+              </a:schemeClr>
+            </a:gs>
+            <a:gs pos="100000">
+              <a:schemeClr val="phClr">
+                <a:lumMod val="99000"/>
+                <a:satMod val="120000"/>
+                <a:shade val="78000"/>
+              </a:schemeClr>
+            </a:gs>
+          </a:gsLst>
+          <a:lin ang="5400000" scaled="0"/>
+        </a:gradFill>
+      </a:fillStyleLst>
+      <a:lnStyleLst>
+        <a:ln w="6350" cap="flat" cmpd="sng" algn="ctr">
+          <a:solidFill>
+            <a:schemeClr val="phClr"/>
+          </a:solidFill>
+          <a:prstDash val="solid"/>
+          <a:miter lim="800000"/>
+        </a:ln>
+        <a:ln w="12700" cap="flat" cmpd="sng" algn="ctr">
+          <a:solidFill>
+            <a:schemeClr val="phClr"/>
+          </a:solidFill>
+          <a:prstDash val="solid"/>
+          <a:miter lim="800000"/>
+        </a:ln>
+        <a:ln w="19050" cap="flat" cmpd="sng" algn="ctr">
+          <a:solidFill>
+            <a:schemeClr val="phClr"/>
+          </a:solidFill>
+          <a:prstDash val="solid"/>
+          <a:miter lim="800000"/>
+        </a:ln>
+      </a:lnStyleLst>
+      <a:effectStyleLst>
+        <a:effectStyle>
+          <a:effectLst/>
+        </a:effectStyle>
+        <a:effectStyle>
+          <a:effectLst/>
+        </a:effectStyle>
+        <a:effectStyle>
+          <a:effectLst>
+            <a:outerShdw blurRad="57150" dist="19050" dir="5400000" algn="ctr" rotWithShape="0">
+              <a:srgbClr val="000000">
+                <a:alpha val="63000"/>
+              </a:srgbClr>
+            </a:outerShdw>
+          </a:effectLst>
+        </a:effectStyle>
+      </a:effectStyleLst>
+      <a:bgFillStyleLst>
+        <a:solidFill>
+          <a:schemeClr val="phClr"/>
+        </a:solidFill>
+        <a:solidFill>
+          <a:schemeClr val="phClr">
+            <a:tint val="95000"/>
+            <a:satMod val="170000"/>
+          </a:schemeClr>
+        </a:solidFill>
+        <a:gradFill rotWithShape="1">
+          <a:gsLst>
+            <a:gs pos="0">
+              <a:schemeClr val="phClr">
+                <a:tint val="93000"/>
+                <a:satMod val="150000"/>
+                <a:shade val="98000"/>
+                <a:lumMod val="102000"/>
+              </a:schemeClr>
+            </a:gs>
+            <a:gs pos="50000">
+              <a:schemeClr val="phClr">
+                <a:tint val="98000"/>
+                <a:satMod val="130000"/>
+                <a:shade val="90000"/>
+                <a:lumMod val="103000"/>
+              </a:schemeClr>
+            </a:gs>
+            <a:gs pos="100000">
+              <a:schemeClr val="phClr">
+                <a:shade val="63000"/>
+                <a:satMod val="120000"/>
+              </a:schemeClr>
+            </a:gs>
+          </a:gsLst>
+          <a:lin ang="5400000" scaled="0"/>
+        </a:gradFill>
+      </a:bgFillStyleLst>
+    </a:fmtScheme>
+  </a:themeElements>
+  <a:objectDefaults/>
+  <a:extraClrSchemeLst/>
+  <a:extLst>
+    <a:ext uri="{05A4C25C-085E-4340-85A3-A5531E510DB2}">
+      <thm15:themeFamily xmlns:thm15="http://schemas.microsoft.com/office/thememl/2012/main" name="Office Theme" id="{62F939B6-93AF-4DB8-9C6B-D6C7DFDC589F}" vid="{4A3C46E8-61CC-4603-A589-7422A47A8E4A}"/>
+    </a:ext>
+  </a:extLst>
+</a:theme>
 </file>
</xml_diff>